<commit_message>
style(17-architecture-decision-record): apply slide cleanup override for concise readability
Polish carousel presentation slides 2–23 according to editorial standards:

- Truncate narrative bodies to under 25 words per slide (eliminating text walls)
- Single visual anchor layout per slide (code, table, diagram, or checklist)
- Eliminate competing right-hand prose columns to maximize whitespace (>40%)
- Fix language mixing and remove corrupted tokens (e.g., supersedes_ADR, non-latin artifacts)
- Rebuilt media deliverables: 24-slide PDF, PPTX, Dev.to markdown, and Medium publication
</commit_message>
<xml_diff>
--- a/labs/17-architecture-decision-record/result/linkedin/lab-17-architecture-decision-record-carousel.pptx
+++ b/labs/17-architecture-decision-record/result/linkedin/lab-17-architecture-decision-record-carousel.pptx
@@ -617,19 +617,19 @@
           <a:lstStyle/>
           <a:p>
             <a:r>
-              <a:t>SLIDE 10: Output Demo: Parsing Berhasil, Linter Lolos</a:t>
+              <a:t>SLIDE 10: Output Demo: Validasi Integritas Lolos</a:t>
             </a:r>
           </a:p>
           <a:p/>
           <a:p>
             <a:r>
-              <a:t>Mental Model: Clean linter output confirms structural consistency, not architectural correctness.</a:t>
+              <a:t>Mental Model: Clean output verifies structural consistency across the entire record set.</a:t>
             </a:r>
           </a:p>
           <a:p/>
           <a:p>
             <a:r>
-              <a:t>[CLI OUTPUT]</a:t>
+              <a:t>[TERMINAL OUTPUT]</a:t>
             </a:r>
           </a:p>
           <a:p>
@@ -639,42 +639,27 @@
           </a:p>
           <a:p>
             <a:r>
-              <a:t>- === Architecture Decision Record (ADR) Lab ===</a:t>
-            </a:r>
-          </a:p>
-          <a:p>
-            <a:r>
               <a:t>- Successfully parsed 3 ADRs:</a:t>
             </a:r>
           </a:p>
           <a:p>
             <a:r>
-              <a:t>-   - [0001] Use Modular Monolith for Core SaaS ERP | Status: Superseded -&gt; Superseded by ADR 2</a:t>
-            </a:r>
-          </a:p>
-          <a:p>
-            <a:r>
-              <a:t>-   - [0002] Extract Notification Service to Microservice  | Status: Accepted   -&gt; Supersedes ADR 1</a:t>
-            </a:r>
-          </a:p>
-          <a:p>
-            <a:r>
-              <a:t>-   - [0003] Reject Event Sourcing for Order Management    | Status: Rejected  </a:t>
-            </a:r>
-          </a:p>
-          <a:p>
-            <a:r>
-              <a:t>- </a:t>
-            </a:r>
-          </a:p>
-          <a:p>
-            <a:r>
-              <a:t>- Running ADR Integrity Linter...</a:t>
-            </a:r>
-          </a:p>
-          <a:p>
-            <a:r>
-              <a:t>- Integrity check passed! Decision lineage and lifecycle invariants are intact.</a:t>
+              <a:t>-   - [0001] Modular Monolith -&gt; Superseded by ADR 2</a:t>
+            </a:r>
+          </a:p>
+          <a:p>
+            <a:r>
+              <a:t>-   - [0002] Notification Microservice -&gt; Supersedes ADR 1</a:t>
+            </a:r>
+          </a:p>
+          <a:p>
+            <a:r>
+              <a:t>-   - [0003] Event Sourcing -&gt; Rejected</a:t>
+            </a:r>
+          </a:p>
+          <a:p>
+            <a:r>
+              <a:t>- Running ADR Integrity Linter... Integrity check passed!</a:t>
             </a:r>
           </a:p>
           <a:p/>
@@ -745,59 +730,49 @@
           <a:lstStyle/>
           <a:p>
             <a:r>
-              <a:t>SLIDE 11: Apa Artinya Linter Passed di Lab Ini?</a:t>
+              <a:t>SLIDE 11: Lolos Linter Bukan Berarti Keputusan Benar</a:t>
             </a:r>
           </a:p>
           <a:p/>
           <a:p>
             <a:r>
-              <a:t>Mental Model: Linter passing is necessary but not sufficient for architectural soundness.</a:t>
+              <a:t>Mental Model: Linter guarantees structural validity; human judgment ensures architectural soundness.</a:t>
             </a:r>
           </a:p>
           <a:p/>
           <a:p>
             <a:r>
-              <a:t>[YANG DIBUKTIKAN]</a:t>
-            </a:r>
-          </a:p>
-          <a:p>
-            <a:r>
-              <a:t>- Format parsing: judul, status, dan tautan supersesi terstruktur dengan benar.</a:t>
-            </a:r>
-          </a:p>
-          <a:p>
-            <a:r>
-              <a:t>- Monotonik: ID 1, 2, 3 berurutan tanpa celah.</a:t>
-            </a:r>
-          </a:p>
-          <a:p>
-            <a:r>
-              <a:t>- Bidirectional: ADR 1 ↔ ADR 2 memiliki tautan timbal-balik yang lengkap.</a:t>
-            </a:r>
-          </a:p>
-          <a:p>
-            <a:r>
-              <a:t>- Cycle-free: tidak ada sirkuit dalam graf supersesi.</a:t>
-            </a:r>
-          </a:p>
-          <a:p>
-            <a:r>
-              <a:t>[YANG TIDAK DIBUKTIKAN]</a:t>
-            </a:r>
-          </a:p>
-          <a:p>
-            <a:r>
-              <a:t>- Kebenaran keputusan arsitektur di dalam field Content.</a:t>
-            </a:r>
-          </a:p>
-          <a:p>
-            <a:r>
-              <a:t>- Apakah ADR 1 seharusnya benar-benar digantikan ADR 2 di dunia nyata.</a:t>
-            </a:r>
-          </a:p>
-          <a:p>
-            <a:r>
-              <a:t>- Kesiapan sistem untuk production deployment.</a:t>
+              <a:t>[YANG DIBUKTIKAN LINTER]</a:t>
+            </a:r>
+          </a:p>
+          <a:p>
+            <a:r>
+              <a:t>- Nomor ID berurutan tanpa celah.</a:t>
+            </a:r>
+          </a:p>
+          <a:p>
+            <a:r>
+              <a:t>- Relasi timbal-balik utuh tanpa tautan gantung.</a:t>
+            </a:r>
+          </a:p>
+          <a:p>
+            <a:r>
+              <a:t>- Tidak ada siklus ketergantungan antar-dokumen.</a:t>
+            </a:r>
+          </a:p>
+          <a:p>
+            <a:r>
+              <a:t>[TETAP PERLU REVIEW MANUSIA]</a:t>
+            </a:r>
+          </a:p>
+          <a:p>
+            <a:r>
+              <a:t>- Kebenaran argumen teknis di bagian Decision.</a:t>
+            </a:r>
+          </a:p>
+          <a:p>
+            <a:r>
+              <a:t>- Apakah microservice memang solusi tepat bagi tim.</a:t>
             </a:r>
           </a:p>
           <a:p/>
@@ -868,54 +843,49 @@
           <a:lstStyle/>
           <a:p>
             <a:r>
-              <a:t>SLIDE 12: Trade-off: Enforced Structure vs Dokumentasi Fleksibel</a:t>
+              <a:t>SLIDE 12: Trade-off: Struktur Kaku vs Fleksibilitas</a:t>
             </a:r>
           </a:p>
           <a:p/>
           <a:p>
             <a:r>
-              <a:t>Mental Model: Structure enforcement gains verification reliability at the cost of narrative flexibility.</a:t>
+              <a:t>Mental Model: Enforced structure trades narrative flexibility for automated verification.</a:t>
             </a:r>
           </a:p>
           <a:p/>
           <a:p>
             <a:r>
-              <a:t>[ENFORCED STRUCTURE (Lab Ini)]</a:t>
-            </a:r>
-          </a:p>
-          <a:p>
-            <a:r>
-              <a:t>- Regex-based parsing memaksa format fixed (## Context, ## Decision, ## Consequences).</a:t>
-            </a:r>
-          </a:p>
-          <a:p>
-            <a:r>
-              <a:t>- Status wajib dari 5 enum resmi; status informal ditolak parser.</a:t>
-            </a:r>
-          </a:p>
-          <a:p>
-            <a:r>
-              <a:t>- Supersedes/SupersededBy wajib konsisten secara timbal-balik.</a:t>
-            </a:r>
-          </a:p>
-          <a:p>
-            <a:r>
-              <a:t>[FLEKSIBILITAS YANG DILEWATI]</a:t>
-            </a:r>
-          </a:p>
-          <a:p>
-            <a:r>
-              <a:t>- Tidak mendukung ADR yang memerlukan struktur sub-section kustom di luar 3 section wajib.</a:t>
-            </a:r>
-          </a:p>
-          <a:p>
-            <a:r>
-              <a:t>- Tidak memvalidasi kualitas argumen dalam section Decision.</a:t>
-            </a:r>
-          </a:p>
-          <a:p>
-            <a:r>
-              <a:t>- Tidak menangani kasus ADR multi-author atau decision yang melibatkan beberapa sub-system.</a:t>
+              <a:t>[STRUKTUR BAKU (LAB INI)]</a:t>
+            </a:r>
+          </a:p>
+          <a:p>
+            <a:r>
+              <a:t>- Wajib tiga section: Context, Decision, Consequences.</a:t>
+            </a:r>
+          </a:p>
+          <a:p>
+            <a:r>
+              <a:t>- Status dibatasi lima enum resmi.</a:t>
+            </a:r>
+          </a:p>
+          <a:p>
+            <a:r>
+              <a:t>- Memungkinkan CI gate otomatis dan deterministik.</a:t>
+            </a:r>
+          </a:p>
+          <a:p>
+            <a:r>
+              <a:t>[FLEKSIBILITAS YANG DIKORBANKAN]</a:t>
+            </a:r>
+          </a:p>
+          <a:p>
+            <a:r>
+              <a:t>- Tidak mendukung format paragraf naratif bebas.</a:t>
+            </a:r>
+          </a:p>
+          <a:p>
+            <a:r>
+              <a:t>- Memerlukan disiplin tim mengisi field relasi.</a:t>
             </a:r>
           </a:p>
           <a:p/>
@@ -986,24 +956,19 @@
           <a:lstStyle/>
           <a:p>
             <a:r>
-              <a:t>SLIDE 13: Validasi Paralel: Goroutine + Mutex untuk Agregasi Error</a:t>
+              <a:t>SLIDE 13: Validasi Paralel dengan Mutex</a:t>
             </a:r>
           </a:p>
           <a:p/>
           <a:p>
             <a:r>
-              <a:t>Mental Model: Per-record goroutine with mutex aggregation scales validation without shared-state races.</a:t>
+              <a:t>Mental Model: Mutex-protected error aggregation keeps concurrent validation race-safe.</a:t>
             </a:r>
           </a:p>
           <a:p/>
           <a:p>
             <a:r>
-              <a:t>[CONCURRENT VALIDATION PATTERN]</a:t>
-            </a:r>
-          </a:p>
-          <a:p>
-            <a:r>
-              <a:t>- var wg sync.WaitGroup</a:t>
+              <a:t>[CONCURRENT LINTER PATTERN]</a:t>
             </a:r>
           </a:p>
           <a:p>
@@ -1028,27 +993,22 @@
           </a:p>
           <a:p>
             <a:r>
-              <a:t>-         var localErrs []error</a:t>
-            </a:r>
-          </a:p>
-          <a:p>
-            <a:r>
-              <a:t>-         // ... validate rec, append localErrs ...</a:t>
-            </a:r>
-          </a:p>
-          <a:p>
-            <a:r>
-              <a:t>-         if len(localErrs) &gt; 0 {</a:t>
-            </a:r>
-          </a:p>
-          <a:p>
-            <a:r>
-              <a:t>-             mu.Lock(); errs = append(errs, localErrs...); mu.Unlock()</a:t>
-            </a:r>
-          </a:p>
-          <a:p>
-            <a:r>
-              <a:t>-         }</a:t>
+              <a:t>-         localErrs := validate(rec)</a:t>
+            </a:r>
+          </a:p>
+          <a:p>
+            <a:r>
+              <a:t>-         mu.Lock()</a:t>
+            </a:r>
+          </a:p>
+          <a:p>
+            <a:r>
+              <a:t>-         errs = append(errs, localErrs...)</a:t>
+            </a:r>
+          </a:p>
+          <a:p>
+            <a:r>
+              <a:t>-         mu.Unlock()</a:t>
             </a:r>
           </a:p>
           <a:p>
@@ -1059,11 +1019,6 @@
           <a:p>
             <a:r>
               <a:t>- }</a:t>
-            </a:r>
-          </a:p>
-          <a:p>
-            <a:r>
-              <a:t>- wg.Wait()</a:t>
             </a:r>
           </a:p>
           <a:p/>
@@ -1134,59 +1089,54 @@
           <a:lstStyle/>
           <a:p>
             <a:r>
-              <a:t>SLIDE 14: Before vs After: Otomasi Linter Menghilangkan Human Error</a:t>
+              <a:t>SLIDE 14: Sebelum vs Sesudah Validasi Otomatis</a:t>
             </a:r>
           </a:p>
           <a:p/>
           <a:p>
             <a:r>
-              <a:t>Mental Model: Automation closes mechanical review gaps that human reviewers consistently miss.</a:t>
+              <a:t>Mental Model: Automate mechanical relation checks to let reviewers focus on architectural depth.</a:t>
             </a:r>
           </a:p>
           <a:p/>
           <a:p>
             <a:r>
-              <a:t>[SEBELUM LINTER (Manual)]</a:t>
-            </a:r>
-          </a:p>
-          <a:p>
-            <a:r>
-              <a:t>- Lineage break: ADR 1 Superseded by 2, ADR 2 tidak memiliki Supersedes: 1 → TIDAK TERDETEKSI</a:t>
-            </a:r>
-          </a:p>
-          <a:p>
-            <a:r>
-              <a:t>- Non-monotonic ID: ADR 1, ADR 3 meloncat → TIDAK TERDETEKSI selagi tidak inspect semua file</a:t>
-            </a:r>
-          </a:p>
-          <a:p>
-            <a:r>
-              <a:t>- Invalid status 'Draft' masuk ke repo → TIDAK TERDETEKSI oleh regex sederhana</a:t>
-            </a:r>
-          </a:p>
-          <a:p>
-            <a:r>
-              <a:t>- Self-supersession: ADR 1 Superseded by 1 → TIDAK TERDETEKSI</a:t>
-            </a:r>
-          </a:p>
-          <a:p>
-            <a:r>
-              <a:t>[SESUDAH LINTER (Automated)]</a:t>
-            </a:r>
-          </a:p>
-          <a:p>
-            <a:r>
-              <a:t>- Semua kasus di atas ditolak oleh TestLinter_BrokenReferences dalam &lt;1ms</a:t>
-            </a:r>
-          </a:p>
-          <a:p>
-            <a:r>
-              <a:t>- CI gate menolak merge jika linter menemukan error</a:t>
-            </a:r>
-          </a:p>
-          <a:p>
-            <a:r>
-              <a:t>- Concurrent stress test membuktikan tidak ada race pada agregasi error</a:t>
+              <a:t>[REVIEW MANUAL (SEBELUM)]</a:t>
+            </a:r>
+          </a:p>
+          <a:p>
+            <a:r>
+              <a:t>- Tautan supersesi sepihak sering terlewat.</a:t>
+            </a:r>
+          </a:p>
+          <a:p>
+            <a:r>
+              <a:t>- Nomor meloncat sulit disadari saat banyak file.</a:t>
+            </a:r>
+          </a:p>
+          <a:p>
+            <a:r>
+              <a:t>- Status non-standar masuk tanpa sengaja.</a:t>
+            </a:r>
+          </a:p>
+          <a:p>
+            <a:r>
+              <a:t>[LINTER GATE (SESUDAH)]</a:t>
+            </a:r>
+          </a:p>
+          <a:p>
+            <a:r>
+              <a:t>- Semua inkonsistensi ditolak otomatis di CI.</a:t>
+            </a:r>
+          </a:p>
+          <a:p>
+            <a:r>
+              <a:t>- Nomor ID wajib monotonik dan unik.</a:t>
+            </a:r>
+          </a:p>
+          <a:p>
+            <a:r>
+              <a:t>- Relasi timbal-balik divalidasi deterministik.</a:t>
             </a:r>
           </a:p>
           <a:p/>
@@ -1257,64 +1207,49 @@
           <a:lstStyle/>
           <a:p>
             <a:r>
-              <a:t>SLIDE 15: Batasan Lab: Validasi Format, Bukan Kualitas Keputusan</a:t>
+              <a:t>SLIDE 15: Batasan Lab: Hanya Validasi Format</a:t>
             </a:r>
           </a:p>
           <a:p/>
           <a:p>
             <a:r>
-              <a:t>Mental Model: Format validation ensures structural integrity; it does not evaluate architectural soundness.</a:t>
+              <a:t>Mental Model: Format validation ensures structural compliance, not business correctness.</a:t>
             </a:r>
           </a:p>
           <a:p/>
           <a:p>
             <a:r>
-              <a:t>[YANG DILAKUKAN LAB]</a:t>
-            </a:r>
-          </a:p>
-          <a:p>
-            <a:r>
-              <a:t>- Parsing teks Markdown ke struct Record dengan regex.</a:t>
-            </a:r>
-          </a:p>
-          <a:p>
-            <a:r>
-              <a:t>- Memvalidasi urutan ID monotonik dan uniqueness.</a:t>
-            </a:r>
-          </a:p>
-          <a:p>
-            <a:r>
-              <a:t>- Memeriksa konsistensi timbal-balik SupersededBy ↔ Supersedes.</a:t>
-            </a:r>
-          </a:p>
-          <a:p>
-            <a:r>
-              <a:t>- Mendeteksi siklus dalam graf supersesi.</a:t>
-            </a:r>
-          </a:p>
-          <a:p>
-            <a:r>
-              <a:t>[YANG TIDAK DILAKUKAN LAB]</a:t>
-            </a:r>
-          </a:p>
-          <a:p>
-            <a:r>
-              <a:t>- Tidak menilai kualitas argumen di dalam section Decision.</a:t>
-            </a:r>
-          </a:p>
-          <a:p>
-            <a:r>
-              <a:t>- Tidak memverifikasi apakah ADR cocok dengan implementasi kode aktual.</a:t>
-            </a:r>
-          </a:p>
-          <a:p>
-            <a:r>
-              <a:t>- Tidak memeriksa apakah engineer sudah mendapatkan approval stakeholder sebelum Accepted.</a:t>
-            </a:r>
-          </a:p>
-          <a:p>
-            <a:r>
-              <a:t>- Simulasi ini tidak sama dengan production ADR management system seperti ADRtool atau Architect.js.</a:t>
+              <a:t>[YANG DIUJI DI LAB]</a:t>
+            </a:r>
+          </a:p>
+          <a:p>
+            <a:r>
+              <a:t>- Ekstraksi regex dari string Markdown.</a:t>
+            </a:r>
+          </a:p>
+          <a:p>
+            <a:r>
+              <a:t>- Pemeriksaan nomor urut dan relasi timbal-balik.</a:t>
+            </a:r>
+          </a:p>
+          <a:p>
+            <a:r>
+              <a:t>- Deteksi siklus pada graf supersesi.</a:t>
+            </a:r>
+          </a:p>
+          <a:p>
+            <a:r>
+              <a:t>[BATASAN BUKTI]</a:t>
+            </a:r>
+          </a:p>
+          <a:p>
+            <a:r>
+              <a:t>- Tidak menilai kebenaran argumen keputusan.</a:t>
+            </a:r>
+          </a:p>
+          <a:p>
+            <a:r>
+              <a:t>- Simulasi in-memory, bukan pembacaan ribuan file disk.</a:t>
             </a:r>
           </a:p>
           <a:p/>
@@ -1385,54 +1320,39 @@
           <a:lstStyle/>
           <a:p>
             <a:r>
-              <a:t>SLIDE 16: Edge Case: Keputusan Dibatalkan Tanpa ADR Baru</a:t>
+              <a:t>SLIDE 16: Kasus Batas: Menghentikan Fitur Tanpa ADR</a:t>
             </a:r>
           </a:p>
           <a:p/>
           <a:p>
             <a:r>
-              <a:t>Mental Model: Silent feature deletion without Deprecated ADR creates documentation-reality gap.</a:t>
+              <a:t>Mental Model: Feature deprecation requires an explicit ADR, not silent file deletion.</a:t>
             </a:r>
           </a:p>
           <a:p/>
           <a:p>
             <a:r>
-              <a:t>[SKENARIO EDGE CASE]</a:t>
-            </a:r>
-          </a:p>
-          <a:p>
-            <a:r>
-              <a:t>- ADR X berstatus Accepted, tapi tim memutuskan berhenti menggunakan fitur tersebut.</a:t>
-            </a:r>
-          </a:p>
-          <a:p>
-            <a:r>
-              <a:t>- Tanpa ADR baru, status ADR X tetap Accepted —误导 engineer lain以为 masih relevan.</a:t>
-            </a:r>
-          </a:p>
-          <a:p>
-            <a:r>
-              <a:t>- Solusi: buat ADR baru berstatus Deprecated merujuk ke alasan penghentian.</a:t>
-            </a:r>
-          </a:p>
-          <a:p>
-            <a:r>
-              <a:t>- Kegagalan: engineer menghapus file ADR langsung → lineage history hilang.</a:t>
-            </a:r>
-          </a:p>
-          <a:p>
-            <a:r>
-              <a:t>[REKOMENDASI PRODUKSI]</a:t>
-            </a:r>
-          </a:p>
-          <a:p>
-            <a:r>
-              <a:t>- Wajibkan policy tim: setiap penghentian fitur memerlukan ADR Deprecated baru.</a:t>
-            </a:r>
-          </a:p>
-          <a:p>
-            <a:r>
-              <a:t>- Linter bisa diperluas untuk mendeteksi ADR Accepted yang tidak memiliki successor dalam 12 bulan.</a:t>
+              <a:t>[SKENARIO RISIKO]</a:t>
+            </a:r>
+          </a:p>
+          <a:p>
+            <a:r>
+              <a:t>- Fitur dimatikan tetapi ADR tetap bertanda Accepted.</a:t>
+            </a:r>
+          </a:p>
+          <a:p>
+            <a:r>
+              <a:t>- Engineer baru mengira fitur masih menjadi standar aktif.</a:t>
+            </a:r>
+          </a:p>
+          <a:p>
+            <a:r>
+              <a:t>- Menghapus file justru menghilangkan konteks historis.</a:t>
+            </a:r>
+          </a:p>
+          <a:p>
+            <a:r>
+              <a:t>- Solusi: wajibkan ADR baru berstatus Deprecated.</a:t>
             </a:r>
           </a:p>
           <a:p/>
@@ -1503,59 +1423,34 @@
           <a:lstStyle/>
           <a:p>
             <a:r>
-              <a:t>SLIDE 17: Apa yang Dibuktikan Oleh Test Suite</a:t>
+              <a:t>SLIDE 17: Bukti yang Divalidasi oleh Test Suite</a:t>
             </a:r>
           </a:p>
           <a:p/>
           <a:p>
             <a:r>
-              <a:t>Mental Model: Test coverage proves structural invariants on defined scenarios, not all possible production states.</a:t>
+              <a:t>Mental Model: Tests verify structural logic against defined cases, not all team workflows.</a:t>
             </a:r>
           </a:p>
           <a:p/>
           <a:p>
             <a:r>
-              <a:t>[PARSER TESTS (parser_test.go)]</a:t>
-            </a:r>
-          </a:p>
-          <a:p>
-            <a:r>
-              <a:t>- TestParse_Valid: ID=1, Status=Accepted → PASS</a:t>
-            </a:r>
-          </a:p>
-          <a:p>
-            <a:r>
-              <a:t>- TestParse_Superseded: SupersededBy=2 berhasil diekstrak → PASS</a:t>
-            </a:r>
-          </a:p>
-          <a:p>
-            <a:r>
-              <a:t>- TestParse_Supersedes: Supersedes=1 berhasil diekstrak → PASS</a:t>
-            </a:r>
-          </a:p>
-          <a:p>
-            <a:r>
-              <a:t>- TestParse_Invalid: missing_title, missing_status, invalid_status, empty sections → semua PASS</a:t>
-            </a:r>
-          </a:p>
-          <a:p>
-            <a:r>
-              <a:t>[LINTER TESTS (linter_test.go)]</a:t>
-            </a:r>
-          </a:p>
-          <a:p>
-            <a:r>
-              <a:t>- TestLinter_ValidSequence: 3 ADR valid, zero errors → PASS</a:t>
-            </a:r>
-          </a:p>
-          <a:p>
-            <a:r>
-              <a:t>- TestLinter_BrokenReferences: 7 sub-case (non-existent ref, mismatch, non-monotonic, self-super, duplicate ID, cyclical) → semua PASS</a:t>
-            </a:r>
-          </a:p>
-          <a:p>
-            <a:r>
-              <a:t>- TestLinter_ConcurrencyStress: concurrent validation, no data race → PASS</a:t>
+              <a:t>[FAKTA TEST SUITE]</a:t>
+            </a:r>
+          </a:p>
+          <a:p>
+            <a:r>
+              <a:t>- Parser menolak status ilegal dan format tanpa judul.</a:t>
+            </a:r>
+          </a:p>
+          <a:p>
+            <a:r>
+              <a:t>- Linter menangkap 7 skenario referensi patah dan tautan gantung.</a:t>
+            </a:r>
+          </a:p>
+          <a:p>
+            <a:r>
+              <a:t>- Race detector bersih pada eksekusi pengujian konkuren.</a:t>
             </a:r>
           </a:p>
           <a:p/>
@@ -1626,49 +1521,39 @@
           <a:lstStyle/>
           <a:p>
             <a:r>
-              <a:t>SLIDE 18: Apa yang Tidak Dibuktikan Oleh Test Suite</a:t>
+              <a:t>SLIDE 18: Batas Integritas: Apa yang Tidak Diuji</a:t>
             </a:r>
           </a:p>
           <a:p/>
           <a:p>
             <a:r>
-              <a:t>Mental Model: Unit tests prove behavior on defined inputs; they do not guarantee production behavior.</a:t>
+              <a:t>Mental Model: Passing tests confirm rule execution; production requires holistic architectural governance.</a:t>
             </a:r>
           </a:p>
           <a:p/>
           <a:p>
             <a:r>
-              <a:t>[BUKAN BUKNIT TEST]</a:t>
-            </a:r>
-          </a:p>
-          <a:p>
-            <a:r>
-              <a:t>- Kebenaran konten arsitektur di dalam section Decision dan Consequences.</a:t>
-            </a:r>
-          </a:p>
-          <a:p>
-            <a:r>
-              <a:t>- Adopsi ADR oleh seluruh anggota tim sesuai format yang ditetapkan.</a:t>
-            </a:r>
-          </a:p>
-          <a:p>
-            <a:r>
-              <a:t>- Integrasi linter dengan CI/CD pipeline (hanya test Go murni, bukan GitHub Actions).</a:t>
-            </a:r>
-          </a:p>
-          <a:p>
-            <a:r>
-              <a:t>- Skalabilitas linter pada ribuan ADR (hanya 3 record dalam demo, 3-7 dalam test).</a:t>
-            </a:r>
-          </a:p>
-          <a:p>
-            <a:r>
-              <a:t>[SIMULASI IN-MEMORY]</a:t>
-            </a:r>
-          </a:p>
-          <a:p>
-            <a:r>
-              <a:t>- Parser bekerja pada string literal, bukan file system read dari ribuan dokumen Markdown.</a:t>
+              <a:t>[DI LUAR CAKUPAN PENGUJIAN]</a:t>
+            </a:r>
+          </a:p>
+          <a:p>
+            <a:r>
+              <a:t>- Kebenaran konten teknis di dalam section Decision.</a:t>
+            </a:r>
+          </a:p>
+          <a:p>
+            <a:r>
+              <a:t>- Disiplin tim dalam memperbarui ADR saat arsitektur bergeser.</a:t>
+            </a:r>
+          </a:p>
+          <a:p>
+            <a:r>
+              <a:t>- Kesiapan sistem monolit atau microservice di production.</a:t>
+            </a:r>
+          </a:p>
+          <a:p>
+            <a:r>
+              <a:t>- Performa I/O disk pada ribuan berkas dokumen.</a:t>
             </a:r>
           </a:p>
           <a:p/>
@@ -1739,49 +1624,34 @@
           <a:lstStyle/>
           <a:p>
             <a:r>
-              <a:t>SLIDE 19: Risiko Produksi: False Confidence dari Linter Hijau</a:t>
+              <a:t>SLIDE 19: Risiko Kepalsuan: Linter Hijau Bukan Aman</a:t>
             </a:r>
           </a:p>
           <a:p/>
           <a:p>
             <a:r>
-              <a:t>Mental Model: A green linter pass validates structure, not wisdom. Human review remains irreplaceable.</a:t>
+              <a:t>Mental Model: Green linter verifies syntax; architectural soundness demands human scrutiny.</a:t>
             </a:r>
           </a:p>
           <a:p/>
           <a:p>
             <a:r>
-              <a:t>[FALSE POSITIVE RISKS]</a:t>
-            </a:r>
-          </a:p>
-          <a:p>
-            <a:r>
-              <a:t>- Tim percaya ADR collection-nya 'bersih' hanya karena linter passing, padahal argumen Decision lemah.</a:t>
-            </a:r>
-          </a:p>
-          <a:p>
-            <a:r>
-              <a:t>- Engineer bisa mengisi Content dengan placeholder kosong selama section ada → linter tetap passing.</a:t>
-            </a:r>
-          </a:p>
-          <a:p>
-            <a:r>
-              <a:t>- Policy tim yang tidak enforcing bisa di-skip tanpa konsekuensi jika gate CI tidak dipasang.</a:t>
-            </a:r>
-          </a:p>
-          <a:p>
-            <a:r>
-              <a:t>[MITIGASI]</a:t>
-            </a:r>
-          </a:p>
-          <a:p>
-            <a:r>
-              <a:t>- Tambah human review checkpoint: ADR Accepted wajib ditinjau architecture board.</a:t>
-            </a:r>
-          </a:p>
-          <a:p>
-            <a:r>
-              <a:t>- Validasi minimum content length pada section Context dan Decision.</a:t>
+              <a:t>[POTENSI KESALAHAN]</a:t>
+            </a:r>
+          </a:p>
+          <a:p>
+            <a:r>
+              <a:t>- Dokumen lolos linter meski bagian Decision hanya berisi teks formalitas.</a:t>
+            </a:r>
+          </a:p>
+          <a:p>
+            <a:r>
+              <a:t>- Tim mengira arsitektur sudah matang hanya karena status CI hijau.</a:t>
+            </a:r>
+          </a:p>
+          <a:p>
+            <a:r>
+              <a:t>- Mitigasi: pertahankan review arsitek untuk menilai isi substansi.</a:t>
             </a:r>
           </a:p>
           <a:p/>
@@ -1852,7 +1722,7 @@
           <a:lstStyle/>
           <a:p>
             <a:r>
-              <a:t>SLIDE 2: Konteks Keputusan Arsitektur Hilang Tanpa Jejak</a:t>
+              <a:t>SLIDE 2: Konteks Arsitektur Hilang Tanpa Jejak</a:t>
             </a:r>
           </a:p>
           <a:p/>
@@ -1869,32 +1739,17 @@
           </a:p>
           <a:p>
             <a:r>
-              <a:t>- Putaran architect merangkap code review: pertanyaan berulang 'kenapa kita pilih X?' di every PR.</a:t>
-            </a:r>
-          </a:p>
-          <a:p>
-            <a:r>
-              <a:t>- Keputusan diambil via chat atau meeting, lalu tenggelam dalam commit history.</a:t>
-            </a:r>
-          </a:p>
-          <a:p>
-            <a:r>
-              <a:t>- ADR lama tidak diperbarui saat sistem berubah; status dokumentasi drift dari kode aktual.</a:t>
-            </a:r>
-          </a:p>
-          <a:p>
-            <a:r>
-              <a:t>[RISIKO BISNIS]</a:t>
-            </a:r>
-          </a:p>
-          <a:p>
-            <a:r>
-              <a:t>- Re-debate arsitektur lama memakan waktu engineering sprint tanpa solusi baru.</a:t>
-            </a:r>
-          </a:p>
-          <a:p>
-            <a:r>
-              <a:t>- Keputusan yang salah diterapkan karena engineer tidak mengetahui ADR penggantian.</a:t>
+              <a:t>- Keputusan arsitektur diambil via chat atau meeting tanpa catatan formal.</a:t>
+            </a:r>
+          </a:p>
+          <a:p>
+            <a:r>
+              <a:t>- Pertanyaan berulang muncul di review kode: mengapa sistem dibangun begini?</a:t>
+            </a:r>
+          </a:p>
+          <a:p>
+            <a:r>
+              <a:t>- ADR lama tidak diperbarui, sehingga status dokumen berbeda dari kode aktual.</a:t>
             </a:r>
           </a:p>
           <a:p/>
@@ -1965,49 +1820,39 @@
           <a:lstStyle/>
           <a:p>
             <a:r>
-              <a:t>SLIDE 20: Implementation Checklist: Menerapkan ADR Linter di Tim</a:t>
+              <a:t>SLIDE 20: Panduan Implementasi Linter ADR di Tim</a:t>
             </a:r>
           </a:p>
           <a:p/>
           <a:p>
             <a:r>
-              <a:t>Mental Model: Checklist ensures consistent adoption; culture change ensures sustained compliance.</a:t>
+              <a:t>Mental Model: Pair clear Markdown standards with automated CI gates to prevent drift.</a:t>
             </a:r>
           </a:p>
           <a:p/>
           <a:p>
             <a:r>
-              <a:t>[CHECKLIST LANGKAH]</a:t>
-            </a:r>
-          </a:p>
-          <a:p>
-            <a:r>
-              <a:t>- [ ] Define ADR template Markdown dengan 3 section wajib: Context, Decision, Consequences.</a:t>
-            </a:r>
-          </a:p>
-          <a:p>
-            <a:r>
-              <a:t>- [ ] Implement parser regex yang mengekstrak ID, Title, Status, SupersededBy, Supersedes.</a:t>
-            </a:r>
-          </a:p>
-          <a:p>
-            <a:r>
-              <a:t>- [ ] Tambahkan status enum valid (Proposed, Accepted, Superseded, Deprecated, Rejected).</a:t>
-            </a:r>
-          </a:p>
-          <a:p>
-            <a:r>
-              <a:t>- [ ] Implement linter dengan validasi monotonik + bidirectional supersession + cycle detection.</a:t>
-            </a:r>
-          </a:p>
-          <a:p>
-            <a:r>
-              <a:t>- [ ] Integrasikan ke CI/CD: go test ./... atau custom binary di PR gate.</a:t>
-            </a:r>
-          </a:p>
-          <a:p>
-            <a:r>
-              <a:t>- [ ] Dokumentasikan policy tim: setiap perubahan keputusan wajib ADR baru, bukan edit retroaktif.</a:t>
+              <a:t>[LANGKAH KERJA]</a:t>
+            </a:r>
+          </a:p>
+          <a:p>
+            <a:r>
+              <a:t>- [ ] Tetapkan template Markdown dengan Context, Decision, Consequences.</a:t>
+            </a:r>
+          </a:p>
+          <a:p>
+            <a:r>
+              <a:t>- [ ] Gunakan enum status resmi (Accepted, Superseded, Rejected, dll.).</a:t>
+            </a:r>
+          </a:p>
+          <a:p>
+            <a:r>
+              <a:t>- [ ] Pasang parser dan linter pada pull request CI gate.</a:t>
+            </a:r>
+          </a:p>
+          <a:p>
+            <a:r>
+              <a:t>- [ ] Larang edit retroaktif: keputusan baru wajib nomor ADR baru.</a:t>
             </a:r>
           </a:p>
           <a:p/>
@@ -2078,44 +1923,39 @@
           <a:lstStyle/>
           <a:p>
             <a:r>
-              <a:t>SLIDE 21: Anti-Pattern: 5 Kebiasaan Buruk Saat Mengadopsi ADR</a:t>
+              <a:t>SLIDE 21: Anti-Pattern: Kesalahan Adopsi ADR</a:t>
             </a:r>
           </a:p>
           <a:p/>
           <a:p>
             <a:r>
-              <a:t>Mental Model: ADR anti-patterns are cultural; linter catches structural symptoms, not behavioral roots.</a:t>
+              <a:t>Mental Model: Never overwrite historical decisions; publish a new record to maintain lineage.</a:t>
             </a:r>
           </a:p>
           <a:p/>
           <a:p>
             <a:r>
-              <a:t>[ANTI-PATTERN SERING TERJADI]</a:t>
-            </a:r>
-          </a:p>
-          <a:p>
-            <a:r>
-              <a:t>- Mengklik ADR untuk segala hal: refactor kecil, penamaan variabel → noise berlebihan.</a:t>
-            </a:r>
-          </a:p>
-          <a:p>
-            <a:r>
-              <a:t>- Mengedit ADR yang sudah Accepted secara silent, tanpa membuat ADR baru (retroactive edit).</a:t>
-            </a:r>
-          </a:p>
-          <a:p>
-            <a:r>
-              <a:t>- Menulis ADR hanya sebagai catatan meeting tanpa section Decision yang eksplisit.</a:t>
-            </a:r>
-          </a:p>
-          <a:p>
-            <a:r>
-              <a:t>- Status 'Draft' bertahan terlalu lama tanpa transisi ke Accepted atau Rejected.</a:t>
-            </a:r>
-          </a:p>
-          <a:p>
-            <a:r>
-              <a:t>- Melupakan update SupersededBy pada ADR lama saat ADR baru dibuat.</a:t>
+              <a:t>[HINDARI POLA INI]</a:t>
+            </a:r>
+          </a:p>
+          <a:p>
+            <a:r>
+              <a:t>- Menulis ADR untuk hal sepele seperti penamaan variabel.</a:t>
+            </a:r>
+          </a:p>
+          <a:p>
+            <a:r>
+              <a:t>- Mengedit ADR Accepted diam-diam alih-alih membuat pengganti.</a:t>
+            </a:r>
+          </a:p>
+          <a:p>
+            <a:r>
+              <a:t>- Membiarkan status Draft berbulan-bulan tanpa kejelasan.</a:t>
+            </a:r>
+          </a:p>
+          <a:p>
+            <a:r>
+              <a:t>- Lupa mencatat nomor ADR pengganti saat membuat keputusan baru.</a:t>
             </a:r>
           </a:p>
           <a:p/>
@@ -2186,13 +2026,13 @@
           <a:lstStyle/>
           <a:p>
             <a:r>
-              <a:t>SLIDE 22: Reproduksi Mandiri: Jalankan Demo dan Test di Lokal</a:t>
+              <a:t>SLIDE 22: Reproduksi Mandiri di Mesin Lokal</a:t>
             </a:r>
           </a:p>
           <a:p/>
           <a:p>
             <a:r>
-              <a:t>Mental Model: Zero-dependency Go standard library ensures instant reproduction on any machine.</a:t>
+              <a:t>Mental Model: Zero-dependency tests ensure fast, repeatable verification on any developer machine.</a:t>
             </a:r>
           </a:p>
           <a:p/>
@@ -2208,42 +2048,17 @@
           </a:p>
           <a:p>
             <a:r>
-              <a:t>- go test -v ./...</a:t>
-            </a:r>
-          </a:p>
-          <a:p>
-            <a:r>
-              <a:t>- go test -race ./...</a:t>
-            </a:r>
-          </a:p>
-          <a:p>
-            <a:r>
-              <a:t>- go run ./cmd/demo</a:t>
-            </a:r>
-          </a:p>
-          <a:p>
-            <a:r>
-              <a:t>[EXPECTED OUTPUT]</a:t>
-            </a:r>
-          </a:p>
-          <a:p>
-            <a:r>
-              <a:t>- TestParse_*: semua PASS</a:t>
-            </a:r>
-          </a:p>
-          <a:p>
-            <a:r>
-              <a:t>- TestLinter_*: semua PASS (14 sub-case total)</a:t>
-            </a:r>
-          </a:p>
-          <a:p>
-            <a:r>
-              <a:t>- go test -race: race detector clean</a:t>
-            </a:r>
-          </a:p>
-          <a:p>
-            <a:r>
-              <a:t>- Demo: 3 ADR parsed, Integrity check passed</a:t>
+              <a:t>- go test -v ./...    # validasi parser &amp; linter</a:t>
+            </a:r>
+          </a:p>
+          <a:p>
+            <a:r>
+              <a:t>- go test -race ./... # cek race condition</a:t>
+            </a:r>
+          </a:p>
+          <a:p>
+            <a:r>
+              <a:t>- go run ./cmd/demo   # jalankan simulasi 3 ADR</a:t>
             </a:r>
           </a:p>
           <a:p/>
@@ -2314,34 +2129,29 @@
           <a:lstStyle/>
           <a:p>
             <a:r>
-              <a:t>SLIDE 23: ADR Diubah Jadi Data yang Bisa Dicek, Bukan Hanya Dokumen</a:t>
+              <a:t>SLIDE 23: ADR Diubah Jadi Data yang Bisa Dicek</a:t>
             </a:r>
           </a:p>
           <a:p/>
           <a:p>
             <a:r>
-              <a:t>Mental Model: Structured validation catches what human review consistently misses: mechanical relation gaps.</a:t>
+              <a:t>Mental Model: Parser makes ADR structured; linter enforces rules. Decisions remain human.</a:t>
             </a:r>
           </a:p>
           <a:p/>
           <a:p>
             <a:r>
-              <a:t>[PELAJARAN REKAYASA]</a:t>
-            </a:r>
-          </a:p>
-          <a:p>
-            <a:r>
-              <a:t>- ADR yang diparse menjadi struct Record memungkinkan validasi otomatis yang tidak bisa dilakukan humans dengan andal.</a:t>
-            </a:r>
-          </a:p>
-          <a:p>
-            <a:r>
-              <a:t>- Bidirectional supersession link adalah invarian yang paling sering rusak; linter menangkapnya di detik pertama.</a:t>
-            </a:r>
-          </a:p>
-          <a:p>
-            <a:r>
-              <a:t>- Konkurensi goroutine + mutex pattern untuk error aggregation adalah reusable pattern untuk validation framework lain.</a:t>
+              <a:t>[PRINSIP REKAYASA]</a:t>
+            </a:r>
+          </a:p>
+          <a:p>
+            <a:r>
+              <a:t>- ADR terstruktur memungkinkan verifikasi otomatis relasi dokumen.</a:t>
+            </a:r>
+          </a:p>
+          <a:p>
+            <a:r>
+              <a:t>- Linter menutup kelalaian mekanis yang sering luput dari review manusia.</a:t>
             </a:r>
           </a:p>
           <a:p>
@@ -2540,13 +2350,13 @@
           <a:lstStyle/>
           <a:p>
             <a:r>
-              <a:t>SLIDE 3: Review Markdown Manual Lupa Relasi Penggantian</a:t>
+              <a:t>SLIDE 3: Review Manual Melewatkan Relasi Supersesi</a:t>
             </a:r>
           </a:p>
           <a:p/>
           <a:p>
             <a:r>
-              <a:t>Mental Model: Manual review catches content errors but misses structural relation gaps.</a:t>
+              <a:t>Mental Model: Manual review catches content typos but misses broken relationship links.</a:t>
             </a:r>
           </a:p>
           <a:p/>
@@ -2557,32 +2367,17 @@
           </a:p>
           <a:p>
             <a:r>
-              <a:t>- ADR 1 tetap berstatus 'Accepted' padahal sudah diganti ADR 2 — lupa di-update.</a:t>
-            </a:r>
-          </a:p>
-          <a:p>
-            <a:r>
-              <a:t>- ADR 2 menulis 'Supersedes: 1', tapi ADR 1 tidak pernah dicatat 'Superseded by 2'.</a:t>
-            </a:r>
-          </a:p>
-          <a:p>
-            <a:r>
-              <a:t>- Penomoran loncat: ADR 1, ADR 3 langsung — engineer lupa insert ADR 2.</a:t>
-            </a:r>
-          </a:p>
-          <a:p>
-            <a:r>
-              <a:t>- Status informal seperti 'Draft', 'In Review' diterima tanpa penolakan.</a:t>
-            </a:r>
-          </a:p>
-          <a:p>
-            <a:r>
-              <a:t>[CONTOH KASUS NYATA]</a:t>
-            </a:r>
-          </a:p>
-          <a:p>
-            <a:r>
-              <a:t>- ADR 1 ber-status Superseded by 99, padahal ADR 99 belum pernah dibuat.</a:t>
+              <a:t>- ADR baru menyatakan menggantikan ADR lama, tetapi ADR lama tidak diubah.</a:t>
+            </a:r>
+          </a:p>
+          <a:p>
+            <a:r>
+              <a:t>- ADR lama tetap bertanda aktif padahal keputusannya sudah ditinggalkan.</a:t>
+            </a:r>
+          </a:p>
+          <a:p>
+            <a:r>
+              <a:t>- Tautan referensi menunjuk ke nomor yang salah tanpa disadari.</a:t>
             </a:r>
           </a:p>
           <a:p/>
@@ -2653,39 +2448,34 @@
           <a:lstStyle/>
           <a:p>
             <a:r>
-              <a:t>SLIDE 4: ADR Bukan Dokumen, Tapi Record yang Bisa Dicek</a:t>
+              <a:t>SLIDE 4: ADR Bukan Dokumen, Tapi Record</a:t>
             </a:r>
           </a:p>
           <a:p/>
           <a:p>
             <a:r>
-              <a:t>Mental Model: ADR is structured data first, human narrative second; validation catches what humans miss.</a:t>
+              <a:t>Mental Model: ADR is structured data first, human narrative second.</a:t>
             </a:r>
           </a:p>
           <a:p/>
           <a:p>
             <a:r>
-              <a:t>[PRINSIP PENTING]</a:t>
-            </a:r>
-          </a:p>
-          <a:p>
-            <a:r>
-              <a:t>- ADR diolah sebagai data, bukan sekadar teks human-readable.</a:t>
-            </a:r>
-          </a:p>
-          <a:p>
-            <a:r>
-              <a:t>- Parser mengekstrak ID, Title, Status, SupersededBy, Supersedes, Content.</a:t>
-            </a:r>
-          </a:p>
-          <a:p>
-            <a:r>
-              <a:t>- Linter memvalidasi aturan: monotonik ID, valid status, relasi timbal-balik.</a:t>
-            </a:r>
-          </a:p>
-          <a:p>
-            <a:r>
-              <a:t>- Keputusan arsitektur tetap ditulis manusiawi; mesin hanya memeriksa format.</a:t>
+              <a:t>[PRINSIP INTI]</a:t>
+            </a:r>
+          </a:p>
+          <a:p>
+            <a:r>
+              <a:t>- ADR diperlakukan sebagai data terstruktur, bukan sekadar teks bebas.</a:t>
+            </a:r>
+          </a:p>
+          <a:p>
+            <a:r>
+              <a:t>- Field kunci diekstrak: ID, Judul, Status, SupersededBy, dan Supersedes.</a:t>
+            </a:r>
+          </a:p>
+          <a:p>
+            <a:r>
+              <a:t>- Mesin memvalidasi konsistensi; manusia tetap menulis esensi keputusannya.</a:t>
             </a:r>
           </a:p>
           <a:p/>
@@ -2756,54 +2546,39 @@
           <a:lstStyle/>
           <a:p>
             <a:r>
-              <a:t>SLIDE 5: Pipeline: Markdown → Parser → Records → Linter</a:t>
+              <a:t>SLIDE 5: Pipeline Validasi Empat Tahap</a:t>
             </a:r>
           </a:p>
           <a:p/>
           <a:p>
             <a:r>
-              <a:t>Mental Model: Pipeline separates parsing from validation: each stage has a single responsibility.</a:t>
+              <a:t>Mental Model: Separate parsing from validation: simple stages create reliable checks.</a:t>
             </a:r>
           </a:p>
           <a:p/>
           <a:p>
             <a:r>
-              <a:t>[ARCHITECTURE FLOW]</a:t>
-            </a:r>
-          </a:p>
-          <a:p>
-            <a:r>
-              <a:t>- [Markdown ADR Text] → adr.Parser (Regex extraction: ID, Title, Status, refs)</a:t>
-            </a:r>
-          </a:p>
-          <a:p>
-            <a:r>
-              <a:t>- → []*adr.Record (In-Memory Structs)</a:t>
-            </a:r>
-          </a:p>
-          <a:p>
-            <a:r>
-              <a:t>- → adr.Linter.Validate(records)</a:t>
-            </a:r>
-          </a:p>
-          <a:p>
-            <a:r>
-              <a:t>-   ├─ Monotonic numbering check: sort + sequential scan</a:t>
-            </a:r>
-          </a:p>
-          <a:p>
-            <a:r>
-              <a:t>-   ├─ Cycle detection: DFS with visiting/visited states</a:t>
-            </a:r>
-          </a:p>
-          <a:p>
-            <a:r>
-              <a:t>-   └─ Bidirectional lineage: goroutines + sync.Mutex per-record validation</a:t>
-            </a:r>
-          </a:p>
-          <a:p>
-            <a:r>
-              <a:t>- → []error (empty = valid, non-empty = integrity breach)</a:t>
+              <a:t>[VALIDATION PIPELINE]</a:t>
+            </a:r>
+          </a:p>
+          <a:p>
+            <a:r>
+              <a:t>- Markdown Files → adr.Parser (ekstraksi field &amp; status)</a:t>
+            </a:r>
+          </a:p>
+          <a:p>
+            <a:r>
+              <a:t>- → []*adr.Record (in-memory struct)</a:t>
+            </a:r>
+          </a:p>
+          <a:p>
+            <a:r>
+              <a:t>- → adr.Linter (cek urutan ID, siklus, &amp; relasi timbal-balik)</a:t>
+            </a:r>
+          </a:p>
+          <a:p>
+            <a:r>
+              <a:t>- → []error (laporan pelanggaran integritas)</a:t>
             </a:r>
           </a:p>
           <a:p/>
@@ -2874,13 +2649,13 @@
           <a:lstStyle/>
           <a:p>
             <a:r>
-              <a:t>SLIDE 6: Struct Record: Definisi Inti ADR</a:t>
+              <a:t>SLIDE 6: Struct Record: Fondasi Validasi Data</a:t>
             </a:r>
           </a:p>
           <a:p/>
           <a:p>
             <a:r>
-              <a:t>Mental Model: Explicit fields over implicit conventions make structural validation possible.</a:t>
+              <a:t>Mental Model: Explicit fields over implicit conventions enable automated linting.</a:t>
             </a:r>
           </a:p>
           <a:p/>
@@ -2891,56 +2666,6 @@
           </a:p>
           <a:p>
             <a:r>
-              <a:t>- type Status string</a:t>
-            </a:r>
-          </a:p>
-          <a:p>
-            <a:r>
-              <a:t>- </a:t>
-            </a:r>
-          </a:p>
-          <a:p>
-            <a:r>
-              <a:t>- const (</a:t>
-            </a:r>
-          </a:p>
-          <a:p>
-            <a:r>
-              <a:t>-     StatusProposed   Status = "Proposed"</a:t>
-            </a:r>
-          </a:p>
-          <a:p>
-            <a:r>
-              <a:t>-     StatusAccepted   Status = "Accepted"</a:t>
-            </a:r>
-          </a:p>
-          <a:p>
-            <a:r>
-              <a:t>-     StatusSuperseded Status = "Superseded"</a:t>
-            </a:r>
-          </a:p>
-          <a:p>
-            <a:r>
-              <a:t>-     StatusDeprecated Status = "Deprecated"</a:t>
-            </a:r>
-          </a:p>
-          <a:p>
-            <a:r>
-              <a:t>-     StatusRejected   Status = "Rejected"</a:t>
-            </a:r>
-          </a:p>
-          <a:p>
-            <a:r>
-              <a:t>- )</a:t>
-            </a:r>
-          </a:p>
-          <a:p>
-            <a:r>
-              <a:t>- </a:t>
-            </a:r>
-          </a:p>
-          <a:p>
-            <a:r>
               <a:t>- type Record struct {</a:t>
             </a:r>
           </a:p>
@@ -2961,12 +2686,12 @@
           </a:p>
           <a:p>
             <a:r>
-              <a:t>-     SupersededBy int // 0 if not superseded</a:t>
-            </a:r>
-          </a:p>
-          <a:p>
-            <a:r>
-              <a:t>-     Supersedes   int // 0 if does not supersede</a:t>
+              <a:t>-     SupersededBy int // 0 jika aktif</a:t>
+            </a:r>
+          </a:p>
+          <a:p>
+            <a:r>
+              <a:t>-     Supersedes   int // 0 jika tidak menggantikan</a:t>
             </a:r>
           </a:p>
           <a:p>
@@ -3047,13 +2772,13 @@
           <a:lstStyle/>
           <a:p>
             <a:r>
-              <a:t>SLIDE 7: Supersesi Patah: ADR 1 Merujuk ke ADR 99</a:t>
+              <a:t>SLIDE 7: Deteksi Tautan Supersesi Patah</a:t>
             </a:r>
           </a:p>
           <a:p/>
           <a:p>
             <a:r>
-              <a:t>Mental Model: A dangling reference is cheaper to catch at lint time than during an architectural review.</a:t>
+              <a:t>Mental Model: Dangling references are cheaper to catch at lint time than during incident review.</a:t>
             </a:r>
           </a:p>
           <a:p/>
@@ -3064,17 +2789,12 @@
           </a:p>
           <a:p>
             <a:r>
-              <a:t>- superseded points to non-existent:</a:t>
-            </a:r>
-          </a:p>
-          <a:p>
-            <a:r>
-              <a:t>-   ADR 1: Status Superseded by 99</a:t>
-            </a:r>
-          </a:p>
-          <a:p>
-            <a:r>
-              <a:t>-   → Error: superseded by non-existent ADR 99</a:t>
+              <a:t>- ADR 1: Status Superseded by 99</a:t>
+            </a:r>
+          </a:p>
+          <a:p>
+            <a:r>
+              <a:t>- → Error: superseded by non-existent ADR 99</a:t>
             </a:r>
           </a:p>
           <a:p>
@@ -3084,32 +2804,12 @@
           </a:p>
           <a:p>
             <a:r>
-              <a:t>- supersedes points to non-existent:</a:t>
-            </a:r>
-          </a:p>
-          <a:p>
-            <a:r>
-              <a:t>-   ADR 1: Status Accepted, Supersedes: 99</a:t>
-            </a:r>
-          </a:p>
-          <a:p>
-            <a:r>
-              <a:t>-   → Error: supersedes non-existent ADR 99</a:t>
-            </a:r>
-          </a:p>
-          <a:p>
-            <a:r>
-              <a:t>[BUKTI DARI TEST]</a:t>
-            </a:r>
-          </a:p>
-          <a:p>
-            <a:r>
-              <a:t>- TestLinter_BrokenReferences / superseded points to non-existent → PASS</a:t>
-            </a:r>
-          </a:p>
-          <a:p>
-            <a:r>
-              <a:t>- TestLinter_BrokenReferences / supersedes points to non-existent → PASS</a:t>
+              <a:t>- ADR 1: Status Accepted, Supersedes: 99</a:t>
+            </a:r>
+          </a:p>
+          <a:p>
+            <a:r>
+              <a:t>- → Error: supersedes non-existent ADR 99</a:t>
             </a:r>
           </a:p>
           <a:p/>
@@ -3180,44 +2880,39 @@
           <a:lstStyle/>
           <a:p>
             <a:r>
-              <a:t>SLIDE 8: Biaya Tersembunyi: Lineage Drift Tanpa Deteksi</a:t>
+              <a:t>SLIDE 8: Biaya Tersembunyi: Lineage Drift Menumpuk</a:t>
             </a:r>
           </a:p>
           <a:p/>
           <a:p>
             <a:r>
-              <a:t>Mental Model: Unverified lineage drift accumulates silently until a production decision depends on it.</a:t>
+              <a:t>Mental Model: Lineage drift accumulates silently until a new decision depends on stale records.</a:t>
             </a:r>
           </a:p>
           <a:p/>
           <a:p>
             <a:r>
-              <a:t>[DRIFT PATTERN]</a:t>
-            </a:r>
-          </a:p>
-          <a:p>
-            <a:r>
-              <a:t>- Time to detect | Cause | Impact</a:t>
-            </a:r>
-          </a:p>
-          <a:p>
-            <a:r>
-              <a:t>- Instant (CI) | Linter reject di PR | Build gagal, engineer feedback loop cepat</a:t>
-            </a:r>
-          </a:p>
-          <a:p>
-            <a:r>
-              <a:t>- Mingguan | Manual audit dokumentasi | Engineer kebingungan siapa yang aktif</a:t>
-            </a:r>
-          </a:p>
-          <a:p>
-            <a:r>
-              <a:t>- Bulanan | Production incident review | Tim kehilangan konteks keputusan penting</a:t>
-            </a:r>
-          </a:p>
-          <a:p>
-            <a:r>
-              <a:t>- Selamanya | Keputusan salah diterapkan | Sistem berkembang dengan asumsi keliru</a:t>
+              <a:t>[DAMPAK DRIFT DOKUMEN]</a:t>
+            </a:r>
+          </a:p>
+          <a:p>
+            <a:r>
+              <a:t>- Tahap | Deteksi | Dampak</a:t>
+            </a:r>
+          </a:p>
+          <a:p>
+            <a:r>
+              <a:t>- CI Gate | Seketika | PR ditolak, feedback loop cepat</a:t>
+            </a:r>
+          </a:p>
+          <a:p>
+            <a:r>
+              <a:t>- Review Manual | Mingguan | Tim bingung dokumen mana yang aktif</a:t>
+            </a:r>
+          </a:p>
+          <a:p>
+            <a:r>
+              <a:t>- Insiden Sistem | Berbulan-bulan | Keputusan baru berpijak pada asumsi keliru</a:t>
             </a:r>
           </a:p>
           <a:p/>
@@ -3288,49 +2983,34 @@
           <a:lstStyle/>
           <a:p>
             <a:r>
-              <a:t>SLIDE 9: Setup Eksperimen: 3 ADR Evolusi Arsitektur</a:t>
+              <a:t>SLIDE 9: Skenario Demo: Tiga ADR Evolusi Arsitektur</a:t>
             </a:r>
           </a:p>
           <a:p/>
           <a:p>
             <a:r>
-              <a:t>Mental Model: Three ADRs capture one realistic architectural evolution path with valid lineage.</a:t>
+              <a:t>Mental Model: Three records demonstrate full lifecycle: active, superseded, and rejected.</a:t>
             </a:r>
           </a:p>
           <a:p/>
           <a:p>
             <a:r>
-              <a:t>[ADR SEQUENCE]</a:t>
-            </a:r>
-          </a:p>
-          <a:p>
-            <a:r>
-              <a:t>- ADR 0001: Use Modular Monolith for Core SaaS ERP | Status: Superseded by 2</a:t>
-            </a:r>
-          </a:p>
-          <a:p>
-            <a:r>
-              <a:t>- ADR 0002: Extract Notification Service to Microservice | Status: Accepted, Supersedes: 1</a:t>
-            </a:r>
-          </a:p>
-          <a:p>
-            <a:r>
-              <a:t>- ADR 0003: Reject Event Sourcing for Order Management | Status: Rejected</a:t>
-            </a:r>
-          </a:p>
-          <a:p>
-            <a:r>
-              <a:t>- </a:t>
-            </a:r>
-          </a:p>
-          <a:p>
-            <a:r>
-              <a:t>- Test suite: parser_test.go (valid + superseded + supersedes + invalid cases)</a:t>
-            </a:r>
-          </a:p>
-          <a:p>
-            <a:r>
-              <a:t>- Test suite: linter_test.go (valid sequence + 7 broken reference scenarios + concurrency)</a:t>
+              <a:t>[URUTAN KEPUTUSAN]</a:t>
+            </a:r>
+          </a:p>
+          <a:p>
+            <a:r>
+              <a:t>- ADR 0001: Modular Monolith | Superseded by ADR 2</a:t>
+            </a:r>
+          </a:p>
+          <a:p>
+            <a:r>
+              <a:t>- ADR 0002: Notification Microservice | Accepted, Supersedes ADR 1</a:t>
+            </a:r>
+          </a:p>
+          <a:p>
+            <a:r>
+              <a:t>- ADR 0003: Event Sourcing | Rejected (alasan biaya operasional)</a:t>
             </a:r>
           </a:p>
           <a:p/>
@@ -6674,7 +6354,7 @@
               </a:defRPr>
             </a:pPr>
             <a:r>
-              <a:t>Output Demo: Parsing Berhasil, Linter Lolos</a:t>
+              <a:t>Output Demo: Validasi Integritas Lolos</a:t>
             </a:r>
           </a:p>
         </p:txBody>
@@ -6709,7 +6389,7 @@
               </a:defRPr>
             </a:pPr>
             <a:r>
-              <a:t>Terminal menampilkan 3 ADR terparsing dan integrity check passed tanpa error.</a:t>
+              <a:t>Ketiga ADR berhasil diparse dan aturan relasi timbal-balik terpenuhi.</a:t>
             </a:r>
           </a:p>
         </p:txBody>
@@ -6766,32 +6446,23 @@
             </a:r>
             <a:br/>
             <a:r>
-              <a:t>=== Architecture Decision Record (ADR) Lab ===</a:t>
+              <a:t>Successfully parsed 3 ADRs:</a:t>
             </a:r>
             <a:br/>
             <a:r>
-              <a:t>Successfully parsed 3 ADRs:</a:t>
+              <a:t>  - [0001] Modular Monolith -&gt; Superseded by ADR 2</a:t>
             </a:r>
             <a:br/>
             <a:r>
-              <a:t>  - [0001] Use Modular Monolith for Core SaaS ERP | Status: Superseded -&gt; Superseded by ADR 2</a:t>
+              <a:t>  - [0002] Notification Microservice -&gt; Supersedes ADR 1</a:t>
             </a:r>
             <a:br/>
             <a:r>
-              <a:t>  - [0002] Extract Notification Service to Microservice  | Status: Accepted   -&gt; Supersedes ADR 1</a:t>
+              <a:t>  - [0003] Event Sourcing -&gt; Rejected</a:t>
             </a:r>
             <a:br/>
             <a:r>
-              <a:t>  - [0003] Reject Event Sourcing for Order Management    | Status: Rejected  </a:t>
-            </a:r>
-            <a:br/>
-            <a:br/>
-            <a:r>
-              <a:t>Running ADR Integrity Linter...</a:t>
-            </a:r>
-            <a:br/>
-            <a:r>
-              <a:t>Integrity check passed! Decision lineage and lifecycle invariants are intact.</a:t>
+              <a:t>Running ADR Integrity Linter... Integrity check passed!</a:t>
             </a:r>
           </a:p>
         </p:txBody>
@@ -6829,7 +6500,7 @@
               </a:defRPr>
             </a:pPr>
             <a:r>
-              <a:t>Output demo CLI membuktikan bahwa ketiga ADR berhasil diparse dari string Markdown dan diterjemahkan menjadi struct Record. Lineage chain ADR 1 → ADR 2 terdeteksi sebagai valid: ADR 1 berstatus Superseded dengan reference ke 2, dan ADR 2 berstatus Accepted dengan klaim Supersedes: 1. Linter tidak menemukan error apa pun pada validasi monotonicity, cycle detection, maupun bidirectional link integrity.</a:t>
+              <a:t>CLI memverifikasi rantai lineage: ADR 1 dan ADR 2 saling terhubung konsisten, nomor urut rapi, dan tidak ada siklus.</a:t>
             </a:r>
           </a:p>
         </p:txBody>
@@ -6881,7 +6552,7 @@
               </a:defRPr>
             </a:pPr>
             <a:r>
-              <a:t>Clean linter output confirms structural consistency, not architectural correctness.</a:t>
+              <a:t>Clean output verifies structural consistency across the entire record set.</a:t>
             </a:r>
           </a:p>
         </p:txBody>
@@ -6916,7 +6587,7 @@
               </a:defRPr>
             </a:pPr>
             <a:r>
-              <a:t>cmd/demo/main.go • tests/linter_test.go</a:t>
+              <a:t>cmd/demo/main.go</a:t>
             </a:r>
           </a:p>
         </p:txBody>
@@ -7082,7 +6753,7 @@
               </a:defRPr>
             </a:pPr>
             <a:r>
-              <a:t>Apa Artinya Linter Passed di Lab Ini?</a:t>
+              <a:t>Lolos Linter Bukan Berarti Keputusan Benar</a:t>
             </a:r>
           </a:p>
         </p:txBody>
@@ -7117,7 +6788,7 @@
               </a:defRPr>
             </a:pPr>
             <a:r>
-              <a:t>Linter passing membuktikan struktur record konsisten, bukan kebenaran keputusan arsitektur.</a:t>
+              <a:t>Linter memverifikasi format data, bukan kebenaran arsitektur di dalamnya.</a:t>
             </a:r>
           </a:p>
         </p:txBody>
@@ -7152,7 +6823,7 @@
               </a:defRPr>
             </a:pPr>
             <a:r>
-              <a:t>YANG DIBUKTIKAN</a:t>
+              <a:t>YANG DIBUKTIKAN LINTER</a:t>
             </a:r>
           </a:p>
           <a:p>
@@ -7167,7 +6838,7 @@
               </a:defRPr>
             </a:pPr>
             <a:r>
-              <a:t>• Format parsing: judul, status, dan tautan supersesi terstruktur dengan benar.</a:t>
+              <a:t>• Nomor ID berurutan tanpa celah.</a:t>
             </a:r>
           </a:p>
           <a:p>
@@ -7182,7 +6853,7 @@
               </a:defRPr>
             </a:pPr>
             <a:r>
-              <a:t>• Monotonik: ID 1, 2, 3 berurutan tanpa celah.</a:t>
+              <a:t>• Relasi timbal-balik utuh tanpa tautan gantung.</a:t>
             </a:r>
           </a:p>
           <a:p>
@@ -7197,7 +6868,19 @@
               </a:defRPr>
             </a:pPr>
             <a:r>
-              <a:t>• Bidirectional: ADR 1 ↔ ADR 2 memiliki tautan timbal-balik yang lengkap.</a:t>
+              <a:t>• Tidak ada siklus ketergantungan antar-dokumen.</a:t>
+            </a:r>
+          </a:p>
+          <a:p>
+            <a:pPr>
+              <a:defRPr sz="1200" b="1">
+                <a:solidFill>
+                  <a:srgbClr val="087F76"/>
+                </a:solidFill>
+              </a:defRPr>
+            </a:pPr>
+            <a:r>
+              <a:t>TETAP PERLU REVIEW MANUSIA</a:t>
             </a:r>
           </a:p>
           <a:p>
@@ -7212,19 +6895,7 @@
               </a:defRPr>
             </a:pPr>
             <a:r>
-              <a:t>• Cycle-free: tidak ada sirkuit dalam graf supersesi.</a:t>
-            </a:r>
-          </a:p>
-          <a:p>
-            <a:pPr>
-              <a:defRPr sz="1200" b="1">
-                <a:solidFill>
-                  <a:srgbClr val="087F76"/>
-                </a:solidFill>
-              </a:defRPr>
-            </a:pPr>
-            <a:r>
-              <a:t>YANG TIDAK DIBUKTIKAN</a:t>
+              <a:t>• Kebenaran argumen teknis di bagian Decision.</a:t>
             </a:r>
           </a:p>
           <a:p>
@@ -7239,37 +6910,7 @@
               </a:defRPr>
             </a:pPr>
             <a:r>
-              <a:t>• Kebenaran keputusan arsitektur di dalam field Content.</a:t>
-            </a:r>
-          </a:p>
-          <a:p>
-            <a:pPr>
-              <a:spcAft>
-                <a:spcPts val="400"/>
-              </a:spcAft>
-              <a:defRPr sz="1200">
-                <a:solidFill>
-                  <a:srgbClr val="0B1B2D"/>
-                </a:solidFill>
-              </a:defRPr>
-            </a:pPr>
-            <a:r>
-              <a:t>• Apakah ADR 1 seharusnya benar-benar digantikan ADR 2 di dunia nyata.</a:t>
-            </a:r>
-          </a:p>
-          <a:p>
-            <a:pPr>
-              <a:spcAft>
-                <a:spcPts val="400"/>
-              </a:spcAft>
-              <a:defRPr sz="1200">
-                <a:solidFill>
-                  <a:srgbClr val="0B1B2D"/>
-                </a:solidFill>
-              </a:defRPr>
-            </a:pPr>
-            <a:r>
-              <a:t>• Kesiapan sistem untuk production deployment.</a:t>
+              <a:t>• Apakah microservice memang solusi tepat bagi tim.</a:t>
             </a:r>
           </a:p>
         </p:txBody>
@@ -7307,7 +6948,7 @@
               </a:defRPr>
             </a:pPr>
             <a:r>
-              <a:t>Hasil linter yang passing adalah bukti kondisi necessary, bukan sufficient. Ia membuktikan bahwa ketiga ADR memenuhi invariant struktural: format parsable, nomor urut monotonik, dan tautan supersesi timbal-balik utuh. Namun, linter tidak menilai apakah keputusan Modular Monolith memang tepat, atau apakah penolakan Event Sourcing didasarkan pada analisis yang komprehensif. Kualitas substansi keputusan tetap tanggung jawab review manusia.</a:t>
+              <a:t>Linter hanya memastikan dokumen rapi dan tautannya konsisten. Ia tidak bisa menilai apakah keputusan microservice benar secara arsitektur. Kualitas keputusan tetap tanggung jawab tim.</a:t>
             </a:r>
           </a:p>
         </p:txBody>
@@ -7359,7 +7000,7 @@
               </a:defRPr>
             </a:pPr>
             <a:r>
-              <a:t>Linter passing is necessary but not sufficient for architectural soundness.</a:t>
+              <a:t>Linter guarantees structural validity; human judgment ensures architectural soundness.</a:t>
             </a:r>
           </a:p>
         </p:txBody>
@@ -7394,7 +7035,7 @@
               </a:defRPr>
             </a:pPr>
             <a:r>
-              <a:t>labs/17-architecture-decision-record/engineering/03-execution-result.md</a:t>
+              <a:t>engineering/03-execution-result.md</a:t>
             </a:r>
           </a:p>
         </p:txBody>
@@ -7560,7 +7201,7 @@
               </a:defRPr>
             </a:pPr>
             <a:r>
-              <a:t>Trade-off: Enforced Structure vs Dokumentasi Fleksibel</a:t>
+              <a:t>Trade-off: Struktur Kaku vs Fleksibilitas</a:t>
             </a:r>
           </a:p>
         </p:txBody>
@@ -7595,7 +7236,7 @@
               </a:defRPr>
             </a:pPr>
             <a:r>
-              <a:t>Standarisasi format ADR meningkatkan deteksi error, tetapi membatasi ekspresi nuansa konteks.</a:t>
+              <a:t>Penegakan format memudahkan otomasi, namun membatasi gaya penulisan bebas.</a:t>
             </a:r>
           </a:p>
         </p:txBody>
@@ -7630,7 +7271,7 @@
               </a:defRPr>
             </a:pPr>
             <a:r>
-              <a:t>ENFORCED STRUCTURE (LAB INI)</a:t>
+              <a:t>STRUKTUR BAKU (LAB INI)</a:t>
             </a:r>
           </a:p>
           <a:p>
@@ -7645,7 +7286,7 @@
               </a:defRPr>
             </a:pPr>
             <a:r>
-              <a:t>• Regex-based parsing memaksa format fixed (## Context, ## Decision, ## Consequences).</a:t>
+              <a:t>• Wajib tiga section: Context, Decision, Consequences.</a:t>
             </a:r>
           </a:p>
           <a:p>
@@ -7660,7 +7301,7 @@
               </a:defRPr>
             </a:pPr>
             <a:r>
-              <a:t>• Status wajib dari 5 enum resmi; status informal ditolak parser.</a:t>
+              <a:t>• Status dibatasi lima enum resmi.</a:t>
             </a:r>
           </a:p>
           <a:p>
@@ -7675,7 +7316,7 @@
               </a:defRPr>
             </a:pPr>
             <a:r>
-              <a:t>• Supersedes/SupersededBy wajib konsisten secara timbal-balik.</a:t>
+              <a:t>• Memungkinkan CI gate otomatis dan deterministik.</a:t>
             </a:r>
           </a:p>
           <a:p>
@@ -7687,7 +7328,7 @@
               </a:defRPr>
             </a:pPr>
             <a:r>
-              <a:t>FLEKSIBILITAS YANG DILEWATI</a:t>
+              <a:t>FLEKSIBILITAS YANG DIKORBANKAN</a:t>
             </a:r>
           </a:p>
           <a:p>
@@ -7702,7 +7343,7 @@
               </a:defRPr>
             </a:pPr>
             <a:r>
-              <a:t>• Tidak mendukung ADR yang memerlukan struktur sub-section kustom di luar 3 section wajib.</a:t>
+              <a:t>• Tidak mendukung format paragraf naratif bebas.</a:t>
             </a:r>
           </a:p>
           <a:p>
@@ -7717,22 +7358,7 @@
               </a:defRPr>
             </a:pPr>
             <a:r>
-              <a:t>• Tidak memvalidasi kualitas argumen dalam section Decision.</a:t>
-            </a:r>
-          </a:p>
-          <a:p>
-            <a:pPr>
-              <a:spcAft>
-                <a:spcPts val="400"/>
-              </a:spcAft>
-              <a:defRPr sz="1200">
-                <a:solidFill>
-                  <a:srgbClr val="0B1B2D"/>
-                </a:solidFill>
-              </a:defRPr>
-            </a:pPr>
-            <a:r>
-              <a:t>• Tidak menangani kasus ADR multi-author atau decision yang melibatkan beberapa sub-system.</a:t>
+              <a:t>• Memerlukan disiplin tim mengisi field relasi.</a:t>
             </a:r>
           </a:p>
         </p:txBody>
@@ -7770,7 +7396,7 @@
               </a:defRPr>
             </a:pPr>
             <a:r>
-              <a:t>Validasi struktural ADR membawa trade-off mendasar: semakin ketat format yang dipaksakan, semakin rendah fleksibilitas penulisan konteks arsitektur. Lab ini memilih path enforceable machine-checkable, artinya parser akan menolak ADR yang tidak mengikuti skema tetap. Di sisi lain, pendekatan ini memungkinkan CI/CD gate yang andal. Tim yang membutuhkan nuansa lebih kaya bisa menambahkan section tambahan di luar yang diparsing, selama tiga section wajib tetap ada.</a:t>
+              <a:t>Format baku membuat dokumen bisa divalidasi mesin di CI. Biayanya: engineer tidak bisa lagi menulis catatan bebas tanpa mengikuti struktur.</a:t>
             </a:r>
           </a:p>
         </p:txBody>
@@ -7822,7 +7448,7 @@
               </a:defRPr>
             </a:pPr>
             <a:r>
-              <a:t>Structure enforcement gains verification reliability at the cost of narrative flexibility.</a:t>
+              <a:t>Enforced structure trades narrative flexibility for automated verification.</a:t>
             </a:r>
           </a:p>
         </p:txBody>
@@ -7857,7 +7483,7 @@
               </a:defRPr>
             </a:pPr>
             <a:r>
-              <a:t>labs/17-architecture-decision-record/content/02-master-draft.md</a:t>
+              <a:t>content/02-master-draft.md</a:t>
             </a:r>
           </a:p>
         </p:txBody>
@@ -8023,7 +7649,7 @@
               </a:defRPr>
             </a:pPr>
             <a:r>
-              <a:t>Validasi Paralel: Goroutine + Mutex untuk Agregasi Error</a:t>
+              <a:t>Validasi Paralel dengan Mutex</a:t>
             </a:r>
           </a:p>
         </p:txBody>
@@ -8058,7 +7684,7 @@
               </a:defRPr>
             </a:pPr>
             <a:r>
-              <a:t>Setiap ADR divalidasi secara independent goroutine, error dikumpulkan dengan sync.Mutex.</a:t>
+              <a:t>Setiap record divalidasi di goroutine terpisah; error dikumpulkan aman.</a:t>
             </a:r>
           </a:p>
         </p:txBody>
@@ -8111,55 +7737,43 @@
               </a:defRPr>
             </a:pPr>
             <a:r>
-              <a:t>var wg sync.WaitGroup</a:t>
+              <a:t>for _, r := range records {</a:t>
             </a:r>
             <a:br/>
             <a:r>
-              <a:t>for _, r := range records {</a:t>
+              <a:t>    wg.Add(1)</a:t>
             </a:r>
             <a:br/>
             <a:r>
-              <a:t>    wg.Add(1)</a:t>
+              <a:t>    go func(rec *Record) {</a:t>
             </a:r>
             <a:br/>
             <a:r>
-              <a:t>    go func(rec *Record) {</a:t>
+              <a:t>        defer wg.Done()</a:t>
             </a:r>
             <a:br/>
             <a:r>
-              <a:t>        defer wg.Done()</a:t>
+              <a:t>        localErrs := validate(rec)</a:t>
             </a:r>
             <a:br/>
             <a:r>
-              <a:t>        var localErrs []error</a:t>
+              <a:t>        mu.Lock()</a:t>
             </a:r>
             <a:br/>
             <a:r>
-              <a:t>        // ... validate rec, append localErrs ...</a:t>
+              <a:t>        errs = append(errs, localErrs...)</a:t>
             </a:r>
             <a:br/>
             <a:r>
-              <a:t>        if len(localErrs) &gt; 0 {</a:t>
+              <a:t>        mu.Unlock()</a:t>
             </a:r>
             <a:br/>
             <a:r>
-              <a:t>            mu.Lock(); errs = append(errs, localErrs...); mu.Unlock()</a:t>
+              <a:t>    }(r)</a:t>
             </a:r>
             <a:br/>
             <a:r>
-              <a:t>        }</a:t>
-            </a:r>
-            <a:br/>
-            <a:r>
-              <a:t>    }(r)</a:t>
-            </a:r>
-            <a:br/>
-            <a:r>
               <a:t>}</a:t>
-            </a:r>
-            <a:br/>
-            <a:r>
-              <a:t>wg.Wait()</a:t>
             </a:r>
           </a:p>
         </p:txBody>
@@ -8197,7 +7811,7 @@
               </a:defRPr>
             </a:pPr>
             <a:r>
-              <a:t>Pola validasi konkuren pada linter menunjukkan praktik Go yang tepat untuk parallel error aggregation. Setiap Record divalidasi dalam goroutine terpisah, menghasilkan slice error lokal yang hanyadigabungkan ke global errs slice setelah acquire mutex. Pola ini menghindari race condition pada write ke shared error slice. Meskipun validasi pada 3 record tidak memberikan gain performa signifikan, pola ini dapat diskalakan untuk hundred-an ADR tanpa perubahan struktur kode.</a:t>
+              <a:t>Validasi konkuren mengumpulkan error memakai mutex. Pola ini race-safe pada test, tetapi nilai utamanya ada pada kejelasan aturan, bukan kecepatan komputasi.</a:t>
             </a:r>
           </a:p>
         </p:txBody>
@@ -8249,7 +7863,7 @@
               </a:defRPr>
             </a:pPr>
             <a:r>
-              <a:t>Per-record goroutine with mutex aggregation scales validation without shared-state races.</a:t>
+              <a:t>Mutex-protected error aggregation keeps concurrent validation race-safe.</a:t>
             </a:r>
           </a:p>
         </p:txBody>
@@ -8450,7 +8064,7 @@
               </a:defRPr>
             </a:pPr>
             <a:r>
-              <a:t>Before vs After: Otomasi Linter Menghilangkan Human Error</a:t>
+              <a:t>Sebelum vs Sesudah Validasi Otomatis</a:t>
             </a:r>
           </a:p>
         </p:txBody>
@@ -8485,7 +8099,7 @@
               </a:defRPr>
             </a:pPr>
             <a:r>
-              <a:t>Membandingkan gap deteksi antara review manual dan automated structural linting.</a:t>
+              <a:t>Celah relasi mekanis yang sering luput ditutup oleh pengecekan linter.</a:t>
             </a:r>
           </a:p>
         </p:txBody>
@@ -8520,7 +8134,7 @@
               </a:defRPr>
             </a:pPr>
             <a:r>
-              <a:t>SEBELUM LINTER (MANUAL)</a:t>
+              <a:t>REVIEW MANUAL (SEBELUM)</a:t>
             </a:r>
           </a:p>
           <a:p>
@@ -8535,7 +8149,7 @@
               </a:defRPr>
             </a:pPr>
             <a:r>
-              <a:t>Lineage break: ADR 1 Superseded by 2, ADR 2 tidak memiliki Supersedes: 1 → TIDAK TERDETEKSI</a:t>
+              <a:t>• Tautan supersesi sepihak sering terlewat.</a:t>
             </a:r>
           </a:p>
           <a:p>
@@ -8550,7 +8164,7 @@
               </a:defRPr>
             </a:pPr>
             <a:r>
-              <a:t>Non-monotonic ID: ADR 1, ADR 3 meloncat → TIDAK TERDETEKSI selagi tidak inspect semua file</a:t>
+              <a:t>• Nomor meloncat sulit disadari saat banyak file.</a:t>
             </a:r>
           </a:p>
           <a:p>
@@ -8565,7 +8179,19 @@
               </a:defRPr>
             </a:pPr>
             <a:r>
-              <a:t>Invalid status 'Draft' masuk ke repo → TIDAK TERDETEKSI oleh regex sederhana</a:t>
+              <a:t>• Status non-standar masuk tanpa sengaja.</a:t>
+            </a:r>
+          </a:p>
+          <a:p>
+            <a:pPr>
+              <a:defRPr sz="1200" b="1">
+                <a:solidFill>
+                  <a:srgbClr val="087F76"/>
+                </a:solidFill>
+              </a:defRPr>
+            </a:pPr>
+            <a:r>
+              <a:t>LINTER GATE (SESUDAH)</a:t>
             </a:r>
           </a:p>
           <a:p>
@@ -8580,19 +8206,7 @@
               </a:defRPr>
             </a:pPr>
             <a:r>
-              <a:t>Self-supersession: ADR 1 Superseded by 1 → TIDAK TERDETEKSI</a:t>
-            </a:r>
-          </a:p>
-          <a:p>
-            <a:pPr>
-              <a:defRPr sz="1200" b="1">
-                <a:solidFill>
-                  <a:srgbClr val="087F76"/>
-                </a:solidFill>
-              </a:defRPr>
-            </a:pPr>
-            <a:r>
-              <a:t>SESUDAH LINTER (AUTOMATED)</a:t>
+              <a:t>• Semua inkonsistensi ditolak otomatis di CI.</a:t>
             </a:r>
           </a:p>
           <a:p>
@@ -8607,7 +8221,7 @@
               </a:defRPr>
             </a:pPr>
             <a:r>
-              <a:t>• Semua kasus di atas ditolak oleh TestLinter_BrokenReferences dalam &lt;1ms</a:t>
+              <a:t>• Nomor ID wajib monotonik dan unik.</a:t>
             </a:r>
           </a:p>
           <a:p>
@@ -8622,22 +8236,7 @@
               </a:defRPr>
             </a:pPr>
             <a:r>
-              <a:t>• CI gate menolak merge jika linter menemukan error</a:t>
-            </a:r>
-          </a:p>
-          <a:p>
-            <a:pPr>
-              <a:spcAft>
-                <a:spcPts val="400"/>
-              </a:spcAft>
-              <a:defRPr sz="1200">
-                <a:solidFill>
-                  <a:srgbClr val="0B1B2D"/>
-                </a:solidFill>
-              </a:defRPr>
-            </a:pPr>
-            <a:r>
-              <a:t>• Concurrent stress test membuktikan tidak ada race pada agregasi error</a:t>
+              <a:t>• Relasi timbal-balik divalidasi deterministik.</a:t>
             </a:r>
           </a:p>
         </p:txBody>
@@ -8675,7 +8274,7 @@
               </a:defRPr>
             </a:pPr>
             <a:r>
-              <a:t>Perbandingan before-after menunjukkan bahwa automasi linter menutup celah deteksi yang secara konsisten terlewatkan pada review manual. Empat skenario failure yang tercatat dalam test suite—dangling reference, mismatched link, non-monotonic ID, dan self-supersession—semuanya lolos dari radar reviewer manusia tetapi langsung tertangkap oleh automated check. Ini bukan berarti linter menggantikan peran arsitek, melainkan mengurangi beban kognitif pada hal-hal yang bersifat mekanis.</a:t>
+              <a:t>Linter menutup human error pada aspek mekanis: tautan sepihak, nomor loncat, dan status informal. Arsitek bisa fokus meninjau substansi keputusan.</a:t>
             </a:r>
           </a:p>
         </p:txBody>
@@ -8727,7 +8326,7 @@
               </a:defRPr>
             </a:pPr>
             <a:r>
-              <a:t>Automation closes mechanical review gaps that human reviewers consistently miss.</a:t>
+              <a:t>Automate mechanical relation checks to let reviewers focus on architectural depth.</a:t>
             </a:r>
           </a:p>
         </p:txBody>
@@ -8928,7 +8527,7 @@
               </a:defRPr>
             </a:pPr>
             <a:r>
-              <a:t>Batasan Lab: Validasi Format, Bukan Kualitas Keputusan</a:t>
+              <a:t>Batasan Lab: Hanya Validasi Format</a:t>
             </a:r>
           </a:p>
         </p:txBody>
@@ -8963,7 +8562,7 @@
               </a:defRPr>
             </a:pPr>
             <a:r>
-              <a:t>Linter memeriksa kepatuhan struktur; ia tidak menilai substansi atau kebenaran argumen.</a:t>
+              <a:t>Lab membuktikan parsing dan relasi; bukan kualitas keputusan arsitektur.</a:t>
             </a:r>
           </a:p>
         </p:txBody>
@@ -8998,7 +8597,7 @@
               </a:defRPr>
             </a:pPr>
             <a:r>
-              <a:t>YANG DILAKUKAN LAB</a:t>
+              <a:t>YANG DIUJI DI LAB</a:t>
             </a:r>
           </a:p>
           <a:p>
@@ -9013,7 +8612,7 @@
               </a:defRPr>
             </a:pPr>
             <a:r>
-              <a:t>• Parsing teks Markdown ke struct Record dengan regex.</a:t>
+              <a:t>• Ekstraksi regex dari string Markdown.</a:t>
             </a:r>
           </a:p>
           <a:p>
@@ -9028,7 +8627,7 @@
               </a:defRPr>
             </a:pPr>
             <a:r>
-              <a:t>• Memvalidasi urutan ID monotonik dan uniqueness.</a:t>
+              <a:t>• Pemeriksaan nomor urut dan relasi timbal-balik.</a:t>
             </a:r>
           </a:p>
           <a:p>
@@ -9043,7 +8642,19 @@
               </a:defRPr>
             </a:pPr>
             <a:r>
-              <a:t>• Memeriksa konsistensi timbal-balik SupersededBy ↔ Supersedes.</a:t>
+              <a:t>• Deteksi siklus pada graf supersesi.</a:t>
+            </a:r>
+          </a:p>
+          <a:p>
+            <a:pPr>
+              <a:defRPr sz="1200" b="1">
+                <a:solidFill>
+                  <a:srgbClr val="087F76"/>
+                </a:solidFill>
+              </a:defRPr>
+            </a:pPr>
+            <a:r>
+              <a:t>BATASAN BUKTI</a:t>
             </a:r>
           </a:p>
           <a:p>
@@ -9058,19 +8669,7 @@
               </a:defRPr>
             </a:pPr>
             <a:r>
-              <a:t>• Mendeteksi siklus dalam graf supersesi.</a:t>
-            </a:r>
-          </a:p>
-          <a:p>
-            <a:pPr>
-              <a:defRPr sz="1200" b="1">
-                <a:solidFill>
-                  <a:srgbClr val="087F76"/>
-                </a:solidFill>
-              </a:defRPr>
-            </a:pPr>
-            <a:r>
-              <a:t>YANG TIDAK DILAKUKAN LAB</a:t>
+              <a:t>• Tidak menilai kebenaran argumen keputusan.</a:t>
             </a:r>
           </a:p>
           <a:p>
@@ -9085,52 +8684,7 @@
               </a:defRPr>
             </a:pPr>
             <a:r>
-              <a:t>• Tidak menilai kualitas argumen di dalam section Decision.</a:t>
-            </a:r>
-          </a:p>
-          <a:p>
-            <a:pPr>
-              <a:spcAft>
-                <a:spcPts val="400"/>
-              </a:spcAft>
-              <a:defRPr sz="1200">
-                <a:solidFill>
-                  <a:srgbClr val="0B1B2D"/>
-                </a:solidFill>
-              </a:defRPr>
-            </a:pPr>
-            <a:r>
-              <a:t>• Tidak memverifikasi apakah ADR cocok dengan implementasi kode aktual.</a:t>
-            </a:r>
-          </a:p>
-          <a:p>
-            <a:pPr>
-              <a:spcAft>
-                <a:spcPts val="400"/>
-              </a:spcAft>
-              <a:defRPr sz="1200">
-                <a:solidFill>
-                  <a:srgbClr val="0B1B2D"/>
-                </a:solidFill>
-              </a:defRPr>
-            </a:pPr>
-            <a:r>
-              <a:t>• Tidak memeriksa apakah engineer sudah mendapatkan approval stakeholder sebelum Accepted.</a:t>
-            </a:r>
-          </a:p>
-          <a:p>
-            <a:pPr>
-              <a:spcAft>
-                <a:spcPts val="400"/>
-              </a:spcAft>
-              <a:defRPr sz="1200">
-                <a:solidFill>
-                  <a:srgbClr val="0B1B2D"/>
-                </a:solidFill>
-              </a:defRPr>
-            </a:pPr>
-            <a:r>
-              <a:t>• Simulasi ini tidak sama dengan production ADR management system seperti ADRtool atau Architect.js.</a:t>
+              <a:t>• Simulasi in-memory, bukan pembacaan ribuan file disk.</a:t>
             </a:r>
           </a:p>
         </p:txBody>
@@ -9168,7 +8722,7 @@
               </a:defRPr>
             </a:pPr>
             <a:r>
-              <a:t>Batasan paling penting dari lab ini adalah ia hanya memeriksa kepatuhan format, bukan kebenaran konten. Parser tidak tahu apakah keputusan 'Extract Notification Service to Microservice' adalah keputusan yang tepat—ia hanya memverifikasi bahwa keputusan tersebut ditulis dalam format yang benar dengan relasi supersesi yang konsisten. Klaim validasi otomatis ini berlaku pada jalur yang diuji, bukan jaminan bahwa seluruh ekosistem dokumentasi arsitektur tim sudah bersih.</a:t>
+              <a:t>Lab ini memvalidasi aturan dokumen, bukan kebenaran arsitektur. Parsing regex bekerja pada memori; pengujian tidak membuktikan seluruh perilaku repositori skala raksasa.</a:t>
             </a:r>
           </a:p>
         </p:txBody>
@@ -9220,7 +8774,7 @@
               </a:defRPr>
             </a:pPr>
             <a:r>
-              <a:t>Format validation ensures structural integrity; it does not evaluate architectural soundness.</a:t>
+              <a:t>Format validation ensures structural compliance, not business correctness.</a:t>
             </a:r>
           </a:p>
         </p:txBody>
@@ -9255,7 +8809,7 @@
               </a:defRPr>
             </a:pPr>
             <a:r>
-              <a:t>labs/17-architecture-decision-record/engineering-audit/04-docs-vs-code.md</a:t>
+              <a:t>engineering-audit/04-docs-vs-code.md</a:t>
             </a:r>
           </a:p>
         </p:txBody>
@@ -9421,7 +8975,7 @@
               </a:defRPr>
             </a:pPr>
             <a:r>
-              <a:t>Edge Case: Keputusan Dibatalkan Tanpa ADR Baru</a:t>
+              <a:t>Kasus Batas: Menghentikan Fitur Tanpa ADR</a:t>
             </a:r>
           </a:p>
         </p:txBody>
@@ -9456,7 +9010,7 @@
               </a:defRPr>
             </a:pPr>
             <a:r>
-              <a:t>Engineer menghentikan fitur tanpa membuat ADR Deprecated; state sistem menjadi ambigu.</a:t>
+              <a:t>Keputusan yang ditinggalkan tanpa status Deprecated memicu ambiguitas sistem.</a:t>
             </a:r>
           </a:p>
         </p:txBody>
@@ -9491,7 +9045,7 @@
               </a:defRPr>
             </a:pPr>
             <a:r>
-              <a:t>SKENARIO EDGE CASE</a:t>
+              <a:t>SKENARIO RISIKO</a:t>
             </a:r>
           </a:p>
           <a:p>
@@ -9506,7 +9060,7 @@
               </a:defRPr>
             </a:pPr>
             <a:r>
-              <a:t>• ADR X berstatus Accepted, tapi tim memutuskan berhenti menggunakan fitur tersebut.</a:t>
+              <a:t>• Fitur dimatikan tetapi ADR tetap bertanda Accepted.</a:t>
             </a:r>
           </a:p>
           <a:p>
@@ -9521,7 +9075,7 @@
               </a:defRPr>
             </a:pPr>
             <a:r>
-              <a:t>• Tanpa ADR baru, status ADR X tetap Accepted —误导 engineer lain以为 masih relevan.</a:t>
+              <a:t>• Engineer baru mengira fitur masih menjadi standar aktif.</a:t>
             </a:r>
           </a:p>
           <a:p>
@@ -9536,7 +9090,7 @@
               </a:defRPr>
             </a:pPr>
             <a:r>
-              <a:t>• Solusi: buat ADR baru berstatus Deprecated merujuk ke alasan penghentian.</a:t>
+              <a:t>• Menghapus file justru menghilangkan konteks historis.</a:t>
             </a:r>
           </a:p>
           <a:p>
@@ -9551,49 +9105,7 @@
               </a:defRPr>
             </a:pPr>
             <a:r>
-              <a:t>Kegagalan: engineer menghapus file ADR langsung → lineage history hilang.</a:t>
-            </a:r>
-          </a:p>
-          <a:p>
-            <a:pPr>
-              <a:defRPr sz="1200" b="1">
-                <a:solidFill>
-                  <a:srgbClr val="087F76"/>
-                </a:solidFill>
-              </a:defRPr>
-            </a:pPr>
-            <a:r>
-              <a:t>REKOMENDASI PRODUKSI</a:t>
-            </a:r>
-          </a:p>
-          <a:p>
-            <a:pPr>
-              <a:spcAft>
-                <a:spcPts val="400"/>
-              </a:spcAft>
-              <a:defRPr sz="1200">
-                <a:solidFill>
-                  <a:srgbClr val="0B1B2D"/>
-                </a:solidFill>
-              </a:defRPr>
-            </a:pPr>
-            <a:r>
-              <a:t>• Wajibkan policy tim: setiap penghentian fitur memerlukan ADR Deprecated baru.</a:t>
-            </a:r>
-          </a:p>
-          <a:p>
-            <a:pPr>
-              <a:spcAft>
-                <a:spcPts val="400"/>
-              </a:spcAft>
-              <a:defRPr sz="1200">
-                <a:solidFill>
-                  <a:srgbClr val="0B1B2D"/>
-                </a:solidFill>
-              </a:defRPr>
-            </a:pPr>
-            <a:r>
-              <a:t>• Linter bisa diperluas untuk mendeteksi ADR Accepted yang tidak memiliki successor dalam 12 bulan.</a:t>
+              <a:t>• Solusi: wajibkan ADR baru berstatus Deprecated.</a:t>
             </a:r>
           </a:p>
         </p:txBody>
@@ -9631,7 +9143,7 @@
               </a:defRPr>
             </a:pPr>
             <a:r>
-              <a:t>Kasus tepi yang tidak ditangani oleh linter saat ini adalah penghentian keputusan tanpa dokumentasi formal. Ketika engineer secara diametral menghentikan fitur yang sebelumnya di-accept via ADR, status dokumen tetap Accepted meskipun praktik aktual sudah berubah. Ini menciptakan gap antara dokumentasi dan realitas sistem. Solusi yang direkomendasikan adalah policy tim yang mewajibkan ADR Deprecated sebagai pengganti, bukan penghapusan file.</a:t>
+              <a:t>Menghentikan fitur tanpa ADR Deprecated menciptakan gap antara catatan dan kode aktual. Dokumen lama tetap terlihat aktif dan membingungkan tim berikutnya.</a:t>
             </a:r>
           </a:p>
         </p:txBody>
@@ -9683,7 +9195,7 @@
               </a:defRPr>
             </a:pPr>
             <a:r>
-              <a:t>Silent feature deletion without Deprecated ADR creates documentation-reality gap.</a:t>
+              <a:t>Feature deprecation requires an explicit ADR, not silent file deletion.</a:t>
             </a:r>
           </a:p>
         </p:txBody>
@@ -9718,7 +9230,7 @@
               </a:defRPr>
             </a:pPr>
             <a:r>
-              <a:t>labs/17-architecture-decision-record/content/02-master-draft.md</a:t>
+              <a:t>content/02-master-draft.md</a:t>
             </a:r>
           </a:p>
         </p:txBody>
@@ -9884,7 +9396,7 @@
               </a:defRPr>
             </a:pPr>
             <a:r>
-              <a:t>Apa yang Dibuktikan Oleh Test Suite</a:t>
+              <a:t>Bukti yang Divalidasi oleh Test Suite</a:t>
             </a:r>
           </a:p>
         </p:txBody>
@@ -9919,7 +9431,7 @@
               </a:defRPr>
             </a:pPr>
             <a:r>
-              <a:t>Parser dan linter menutupi semua skenario struktural dasar yang didefinisikan dalam lab.</a:t>
+              <a:t>Suite pengujian membuktikan aturan struktural pada skenario yang dirancang.</a:t>
             </a:r>
           </a:p>
         </p:txBody>
@@ -9954,7 +9466,7 @@
               </a:defRPr>
             </a:pPr>
             <a:r>
-              <a:t>PARSER TESTS (PARSER_TEST.GO)</a:t>
+              <a:t>FAKTA TEST SUITE</a:t>
             </a:r>
           </a:p>
           <a:p>
@@ -9969,7 +9481,7 @@
               </a:defRPr>
             </a:pPr>
             <a:r>
-              <a:t>TestParse_Valid: ID=1, Status=Accepted → PASS</a:t>
+              <a:t>• Parser menolak status ilegal dan format tanpa judul.</a:t>
             </a:r>
           </a:p>
           <a:p>
@@ -9984,7 +9496,7 @@
               </a:defRPr>
             </a:pPr>
             <a:r>
-              <a:t>TestParse_Superseded: SupersededBy=2 berhasil diekstrak → PASS</a:t>
+              <a:t>• Linter menangkap 7 skenario referensi patah dan tautan gantung.</a:t>
             </a:r>
           </a:p>
           <a:p>
@@ -9999,79 +9511,7 @@
               </a:defRPr>
             </a:pPr>
             <a:r>
-              <a:t>TestParse_Supersedes: Supersedes=1 berhasil diekstrak → PASS</a:t>
-            </a:r>
-          </a:p>
-          <a:p>
-            <a:pPr>
-              <a:spcAft>
-                <a:spcPts val="400"/>
-              </a:spcAft>
-              <a:defRPr sz="1200">
-                <a:solidFill>
-                  <a:srgbClr val="0B1B2D"/>
-                </a:solidFill>
-              </a:defRPr>
-            </a:pPr>
-            <a:r>
-              <a:t>TestParse_Invalid: missing_title, missing_status, invalid_status, empty sections → semua PASS</a:t>
-            </a:r>
-          </a:p>
-          <a:p>
-            <a:pPr>
-              <a:defRPr sz="1200" b="1">
-                <a:solidFill>
-                  <a:srgbClr val="087F76"/>
-                </a:solidFill>
-              </a:defRPr>
-            </a:pPr>
-            <a:r>
-              <a:t>LINTER TESTS (LINTER_TEST.GO)</a:t>
-            </a:r>
-          </a:p>
-          <a:p>
-            <a:pPr>
-              <a:spcAft>
-                <a:spcPts val="400"/>
-              </a:spcAft>
-              <a:defRPr sz="1200">
-                <a:solidFill>
-                  <a:srgbClr val="0B1B2D"/>
-                </a:solidFill>
-              </a:defRPr>
-            </a:pPr>
-            <a:r>
-              <a:t>TestLinter_ValidSequence: 3 ADR valid, zero errors → PASS</a:t>
-            </a:r>
-          </a:p>
-          <a:p>
-            <a:pPr>
-              <a:spcAft>
-                <a:spcPts val="400"/>
-              </a:spcAft>
-              <a:defRPr sz="1200">
-                <a:solidFill>
-                  <a:srgbClr val="0B1B2D"/>
-                </a:solidFill>
-              </a:defRPr>
-            </a:pPr>
-            <a:r>
-              <a:t>TestLinter_BrokenReferences: 7 sub-case (non-existent ref, mismatch, non-monotonic, self-super, duplicate ID, cyclical) → semua PASS</a:t>
-            </a:r>
-          </a:p>
-          <a:p>
-            <a:pPr>
-              <a:spcAft>
-                <a:spcPts val="400"/>
-              </a:spcAft>
-              <a:defRPr sz="1200">
-                <a:solidFill>
-                  <a:srgbClr val="0B1B2D"/>
-                </a:solidFill>
-              </a:defRPr>
-            </a:pPr>
-            <a:r>
-              <a:t>TestLinter_ConcurrencyStress: concurrent validation, no data race → PASS</a:t>
+              <a:t>• Race detector bersih pada eksekusi pengujian konkuren.</a:t>
             </a:r>
           </a:p>
         </p:txBody>
@@ -10109,7 +9549,7 @@
               </a:defRPr>
             </a:pPr>
             <a:r>
-              <a:t>Suite pengujian lab ini mencakup 10 test function dengan 18 sub-case yang membuktikan seluruh invariant struktural yang didefinisikan. Parser menangani 6 kasus validasi format (termasuk 9 sub-case invalid). Linter menangani 8 skenario integritas graf (valid sequence, 7 broken reference types). Race detector pada go test -race juga lulus tanpa warning. Bukti ini cakupannya mengikuti skenario test yang didefinisikan — bukan klaim bahwa seluruh kemungkinan edge case production tertutup.</a:t>
+              <a:t>Test membuktikan parser dan linter bekerja sesuai aturan pada skenario uji. Bukti ini menegaskan keandalan logika struktural, bukan jaminan semua kebutuhan tim terpenuhi.</a:t>
             </a:r>
           </a:p>
         </p:txBody>
@@ -10161,7 +9601,7 @@
               </a:defRPr>
             </a:pPr>
             <a:r>
-              <a:t>Test coverage proves structural invariants on defined scenarios, not all possible production states.</a:t>
+              <a:t>Tests verify structural logic against defined cases, not all team workflows.</a:t>
             </a:r>
           </a:p>
         </p:txBody>
@@ -10362,7 +9802,7 @@
               </a:defRPr>
             </a:pPr>
             <a:r>
-              <a:t>Apa yang Tidak Dibuktikan Oleh Test Suite</a:t>
+              <a:t>Batas Integritas: Apa yang Tidak Diuji</a:t>
             </a:r>
           </a:p>
         </p:txBody>
@@ -10397,7 +9837,7 @@
               </a:defRPr>
             </a:pPr>
             <a:r>
-              <a:t>Test hanya menjangkau jalur yang di-skripsikan; production masih perlu validasi tambahan.</a:t>
+              <a:t>Test tidak menggantikan peninjauan arsitektur dan kebijakan kerja tim.</a:t>
             </a:r>
           </a:p>
         </p:txBody>
@@ -10432,7 +9872,7 @@
               </a:defRPr>
             </a:pPr>
             <a:r>
-              <a:t>BUKAN BUKNIT TEST</a:t>
+              <a:t>DI LUAR CAKUPAN PENGUJIAN</a:t>
             </a:r>
           </a:p>
           <a:p>
@@ -10447,7 +9887,7 @@
               </a:defRPr>
             </a:pPr>
             <a:r>
-              <a:t>• Kebenaran konten arsitektur di dalam section Decision dan Consequences.</a:t>
+              <a:t>• Kebenaran konten teknis di dalam section Decision.</a:t>
             </a:r>
           </a:p>
           <a:p>
@@ -10462,7 +9902,7 @@
               </a:defRPr>
             </a:pPr>
             <a:r>
-              <a:t>• Adopsi ADR oleh seluruh anggota tim sesuai format yang ditetapkan.</a:t>
+              <a:t>• Disiplin tim dalam memperbarui ADR saat arsitektur bergeser.</a:t>
             </a:r>
           </a:p>
           <a:p>
@@ -10477,7 +9917,7 @@
               </a:defRPr>
             </a:pPr>
             <a:r>
-              <a:t>• Integrasi linter dengan CI/CD pipeline (hanya test Go murni, bukan GitHub Actions).</a:t>
+              <a:t>• Kesiapan sistem monolit atau microservice di production.</a:t>
             </a:r>
           </a:p>
           <a:p>
@@ -10492,34 +9932,7 @@
               </a:defRPr>
             </a:pPr>
             <a:r>
-              <a:t>• Skalabilitas linter pada ribuan ADR (hanya 3 record dalam demo, 3-7 dalam test).</a:t>
-            </a:r>
-          </a:p>
-          <a:p>
-            <a:pPr>
-              <a:defRPr sz="1200" b="1">
-                <a:solidFill>
-                  <a:srgbClr val="087F76"/>
-                </a:solidFill>
-              </a:defRPr>
-            </a:pPr>
-            <a:r>
-              <a:t>SIMULASI IN-MEMORY</a:t>
-            </a:r>
-          </a:p>
-          <a:p>
-            <a:pPr>
-              <a:spcAft>
-                <a:spcPts val="400"/>
-              </a:spcAft>
-              <a:defRPr sz="1200">
-                <a:solidFill>
-                  <a:srgbClr val="0B1B2D"/>
-                </a:solidFill>
-              </a:defRPr>
-            </a:pPr>
-            <a:r>
-              <a:t>• Parser bekerja pada string literal, bukan file system read dari ribuan dokumen Markdown.</a:t>
+              <a:t>• Performa I/O disk pada ribuan berkas dokumen.</a:t>
             </a:r>
           </a:p>
         </p:txBody>
@@ -10557,7 +9970,7 @@
               </a:defRPr>
             </a:pPr>
             <a:r>
-              <a:t>Penting untuk mengenali batas bukti dari test suite ini. Test tidak menilai kebenaran substansi keputusan arsitektur yang terdapat di dalam field Content. Test juga tidak membuktikan bahwa linter akan bekerja dengan baik ketika diterapkan pada ratusan file ADR di repositori production. Simulasi berjalan pada string literal di dalam kode, bukan pada file system I/O aktual. Klaim validasi struktural yang dihasilkan test berlaku pada jalur yang diuji, bukan generalisasi ke seluruh spektrum kemungkinan error di lapangan.</a:t>
+              <a:t>Test unit membuktikan aturan pada input tertentu. Keberhasilan test bukan bukti bahwa keputusan yang didokumentasikan sudah siap diterapkan di production.</a:t>
             </a:r>
           </a:p>
         </p:txBody>
@@ -10609,7 +10022,7 @@
               </a:defRPr>
             </a:pPr>
             <a:r>
-              <a:t>Unit tests prove behavior on defined inputs; they do not guarantee production behavior.</a:t>
+              <a:t>Passing tests confirm rule execution; production requires holistic architectural governance.</a:t>
             </a:r>
           </a:p>
         </p:txBody>
@@ -10644,7 +10057,7 @@
               </a:defRPr>
             </a:pPr>
             <a:r>
-              <a:t>labs/17-architecture-decision-record/engineering-audit/05-gaps.md</a:t>
+              <a:t>engineering-audit/05-gaps.md</a:t>
             </a:r>
           </a:p>
         </p:txBody>
@@ -10810,7 +10223,7 @@
               </a:defRPr>
             </a:pPr>
             <a:r>
-              <a:t>Risiko Produksi: False Confidence dari Linter Hijau</a:t>
+              <a:t>Risiko Kepalsuan: Linter Hijau Bukan Aman</a:t>
             </a:r>
           </a:p>
         </p:txBody>
@@ -10845,7 +10258,7 @@
               </a:defRPr>
             </a:pPr>
             <a:r>
-              <a:t>Linter passing bisa memberikan ilusi keamanan yang menyesatkan jika substansi tidak dicek manusia.</a:t>
+              <a:t>Lolos validasi struktur dapat memberi rasa aman palsu jika argumen tidak dicek.</a:t>
             </a:r>
           </a:p>
         </p:txBody>
@@ -10880,7 +10293,7 @@
               </a:defRPr>
             </a:pPr>
             <a:r>
-              <a:t>FALSE POSITIVE RISKS</a:t>
+              <a:t>POTENSI KESALAHAN</a:t>
             </a:r>
           </a:p>
           <a:p>
@@ -10895,7 +10308,7 @@
               </a:defRPr>
             </a:pPr>
             <a:r>
-              <a:t>• Tim percaya ADR collection-nya 'bersih' hanya karena linter passing, padahal argumen Decision lemah.</a:t>
+              <a:t>• Dokumen lolos linter meski bagian Decision hanya berisi teks formalitas.</a:t>
             </a:r>
           </a:p>
           <a:p>
@@ -10910,7 +10323,7 @@
               </a:defRPr>
             </a:pPr>
             <a:r>
-              <a:t>Engineer bisa mengisi Content dengan placeholder kosong selama section ada → linter tetap passing.</a:t>
+              <a:t>• Tim mengira arsitektur sudah matang hanya karena status CI hijau.</a:t>
             </a:r>
           </a:p>
           <a:p>
@@ -10925,49 +10338,7 @@
               </a:defRPr>
             </a:pPr>
             <a:r>
-              <a:t>• Policy tim yang tidak enforcing bisa di-skip tanpa konsekuensi jika gate CI tidak dipasang.</a:t>
-            </a:r>
-          </a:p>
-          <a:p>
-            <a:pPr>
-              <a:defRPr sz="1200" b="1">
-                <a:solidFill>
-                  <a:srgbClr val="087F76"/>
-                </a:solidFill>
-              </a:defRPr>
-            </a:pPr>
-            <a:r>
-              <a:t>MITIGASI</a:t>
-            </a:r>
-          </a:p>
-          <a:p>
-            <a:pPr>
-              <a:spcAft>
-                <a:spcPts val="400"/>
-              </a:spcAft>
-              <a:defRPr sz="1200">
-                <a:solidFill>
-                  <a:srgbClr val="0B1B2D"/>
-                </a:solidFill>
-              </a:defRPr>
-            </a:pPr>
-            <a:r>
-              <a:t>• Tambah human review checkpoint: ADR Accepted wajib ditinjau architecture board.</a:t>
-            </a:r>
-          </a:p>
-          <a:p>
-            <a:pPr>
-              <a:spcAft>
-                <a:spcPts val="400"/>
-              </a:spcAft>
-              <a:defRPr sz="1200">
-                <a:solidFill>
-                  <a:srgbClr val="0B1B2D"/>
-                </a:solidFill>
-              </a:defRPr>
-            </a:pPr>
-            <a:r>
-              <a:t>• Validasi minimum content length pada section Context dan Decision.</a:t>
+              <a:t>• Mitigasi: pertahankan review arsitek untuk menilai isi substansi.</a:t>
             </a:r>
           </a:p>
         </p:txBody>
@@ -11005,7 +10376,7 @@
               </a:defRPr>
             </a:pPr>
             <a:r>
-              <a:t>Risiko terbesar dari automasi validasi adalah false confidence. Ketika linter menghasilkan output hijau tanpa error, tim cenderung menganggap seluruh aspek dokumentasi arsitektur sudah OK. Padahal, Content field bisa saja berisi penjelasan yang sangat minim atau bahkan placeholder. Linter passing bukan berarti keputusan arsitektur tersebut berkualitas tinggi — ia hanya berarti formatnya konsisten secara struktural. Mitigasi utamanya adalah mempertahankan human review sebagai gate tambahan.</a:t>
+              <a:t>Linter hijau hanya menjamin format valid, bukan kualitas desain. Jangan jadikan status lolos linter sebagai pengganti telaah arsitektur mendalam oleh engineer senior.</a:t>
             </a:r>
           </a:p>
         </p:txBody>
@@ -11057,7 +10428,7 @@
               </a:defRPr>
             </a:pPr>
             <a:r>
-              <a:t>A green linter pass validates structure, not wisdom. Human review remains irreplaceable.</a:t>
+              <a:t>Green linter verifies syntax; architectural soundness demands human scrutiny.</a:t>
             </a:r>
           </a:p>
         </p:txBody>
@@ -11092,7 +10463,7 @@
               </a:defRPr>
             </a:pPr>
             <a:r>
-              <a:t>labs/17-architecture-decision-record/engineering-audit/06-verdict.md</a:t>
+              <a:t>engineering-audit/06-verdict.md</a:t>
             </a:r>
           </a:p>
         </p:txBody>
@@ -11258,7 +10629,7 @@
               </a:defRPr>
             </a:pPr>
             <a:r>
-              <a:t>Konteks Keputusan Arsitektur Hilang Tanpa Jejak</a:t>
+              <a:t>Konteks Arsitektur Hilang Tanpa Jejak</a:t>
             </a:r>
           </a:p>
         </p:txBody>
@@ -11293,7 +10664,7 @@
               </a:defRPr>
             </a:pPr>
             <a:r>
-              <a:t>Engineer baru bertanya mengapa sistem dibangun begini; tidak ada jawaban yang terekam.</a:t>
+              <a:t>Alasan teknis di balik keputusan kritis sering hilang saat tim bertumbuh.</a:t>
             </a:r>
           </a:p>
         </p:txBody>
@@ -11343,7 +10714,7 @@
               </a:defRPr>
             </a:pPr>
             <a:r>
-              <a:t>• Putaran architect merangkap code review: pertanyaan berulang 'kenapa kita pilih X?' di every PR.</a:t>
+              <a:t>• Keputusan arsitektur diambil via chat atau meeting tanpa catatan formal.</a:t>
             </a:r>
           </a:p>
           <a:p>
@@ -11358,7 +10729,7 @@
               </a:defRPr>
             </a:pPr>
             <a:r>
-              <a:t>• Keputusan diambil via chat atau meeting, lalu tenggelam dalam commit history.</a:t>
+              <a:t>• Pertanyaan berulang muncul di review kode: mengapa sistem dibangun begini?</a:t>
             </a:r>
           </a:p>
           <a:p>
@@ -11373,49 +10744,7 @@
               </a:defRPr>
             </a:pPr>
             <a:r>
-              <a:t>• ADR lama tidak diperbarui saat sistem berubah; status dokumentasi drift dari kode aktual.</a:t>
-            </a:r>
-          </a:p>
-          <a:p>
-            <a:pPr>
-              <a:defRPr sz="1200" b="1">
-                <a:solidFill>
-                  <a:srgbClr val="087F76"/>
-                </a:solidFill>
-              </a:defRPr>
-            </a:pPr>
-            <a:r>
-              <a:t>RISIKO BISNIS</a:t>
-            </a:r>
-          </a:p>
-          <a:p>
-            <a:pPr>
-              <a:spcAft>
-                <a:spcPts val="400"/>
-              </a:spcAft>
-              <a:defRPr sz="1200">
-                <a:solidFill>
-                  <a:srgbClr val="0B1B2D"/>
-                </a:solidFill>
-              </a:defRPr>
-            </a:pPr>
-            <a:r>
-              <a:t>• Re-debate arsitektur lama memakan waktu engineering sprint tanpa solusi baru.</a:t>
-            </a:r>
-          </a:p>
-          <a:p>
-            <a:pPr>
-              <a:spcAft>
-                <a:spcPts val="400"/>
-              </a:spcAft>
-              <a:defRPr sz="1200">
-                <a:solidFill>
-                  <a:srgbClr val="0B1B2D"/>
-                </a:solidFill>
-              </a:defRPr>
-            </a:pPr>
-            <a:r>
-              <a:t>• Keputusan yang salah diterapkan karena engineer tidak mengetahui ADR penggantian.</a:t>
+              <a:t>• ADR lama tidak diperbarui, sehingga status dokumen berbeda dari kode aktual.</a:t>
             </a:r>
           </a:p>
         </p:txBody>
@@ -11453,7 +10782,7 @@
               </a:defRPr>
             </a:pPr>
             <a:r>
-              <a:t>Dalam praktik engineering sehari-hari, keputusan arsitektur sering kali diambil secara informal—lewat chat, voice note, atau diskusi meeting. Ketika engineer baru bergabung atau sistem mengalami pivot strategis, konteks historis mengapa pilihan tertentu dibuat hilang. Tim kemudian terjebak debat berulang tentang keputusan yang sebenarnya sudah pernah diverifikasi dan ditolak. Ini bukan masalah dokumentasi biasa; ini adalah kehilangan kapabilitas keputusan yang berharga.</a:t>
+              <a:t>Keputusan arsitektur sering lahir di chat atau meeting. Saat tim berubah, alasan awalnya hilang. ADR membuat alasan itu bisa ditelusuri lagi.</a:t>
             </a:r>
           </a:p>
         </p:txBody>
@@ -11540,7 +10869,7 @@
               </a:defRPr>
             </a:pPr>
             <a:r>
-              <a:t>labs/17-architecture-decision-record/content/02-master-draft.md</a:t>
+              <a:t>content/02-master-draft.md</a:t>
             </a:r>
           </a:p>
         </p:txBody>
@@ -11706,7 +11035,7 @@
               </a:defRPr>
             </a:pPr>
             <a:r>
-              <a:t>Implementation Checklist: Menerapkan ADR Linter di Tim</a:t>
+              <a:t>Panduan Implementasi Linter ADR di Tim</a:t>
             </a:r>
           </a:p>
         </p:txBody>
@@ -11741,7 +11070,7 @@
               </a:defRPr>
             </a:pPr>
             <a:r>
-              <a:t>Langkah-langkah praktis untuk mengintegrasikan parser-linter ke workflow tim.</a:t>
+              <a:t>Langkah praktis mengintegrasikan validasi dokumen ke dalam workflow repositori.</a:t>
             </a:r>
           </a:p>
         </p:txBody>
@@ -11776,7 +11105,7 @@
               </a:defRPr>
             </a:pPr>
             <a:r>
-              <a:t>CHECKLIST LANGKAH</a:t>
+              <a:t>LANGKAH KERJA</a:t>
             </a:r>
           </a:p>
           <a:p>
@@ -11791,7 +11120,7 @@
               </a:defRPr>
             </a:pPr>
             <a:r>
-              <a:t>• [ ] Define ADR template Markdown dengan 3 section wajib: Context, Decision, Consequences.</a:t>
+              <a:t>• [ ] Tetapkan template Markdown dengan Context, Decision, Consequences.</a:t>
             </a:r>
           </a:p>
           <a:p>
@@ -11806,7 +11135,7 @@
               </a:defRPr>
             </a:pPr>
             <a:r>
-              <a:t>• [ ] Implement parser regex yang mengekstrak ID, Title, Status, SupersededBy, Supersedes.</a:t>
+              <a:t>• [ ] Gunakan enum status resmi (Accepted, Superseded, Rejected, dll.).</a:t>
             </a:r>
           </a:p>
           <a:p>
@@ -11821,7 +11150,7 @@
               </a:defRPr>
             </a:pPr>
             <a:r>
-              <a:t>• [ ] Tambahkan status enum valid (Proposed, Accepted, Superseded, Deprecated, Rejected).</a:t>
+              <a:t>• [ ] Pasang parser dan linter pada pull request CI gate.</a:t>
             </a:r>
           </a:p>
           <a:p>
@@ -11836,37 +11165,7 @@
               </a:defRPr>
             </a:pPr>
             <a:r>
-              <a:t>• [ ] Implement linter dengan validasi monotonik + bidirectional supersession + cycle detection.</a:t>
-            </a:r>
-          </a:p>
-          <a:p>
-            <a:pPr>
-              <a:spcAft>
-                <a:spcPts val="400"/>
-              </a:spcAft>
-              <a:defRPr sz="1200">
-                <a:solidFill>
-                  <a:srgbClr val="0B1B2D"/>
-                </a:solidFill>
-              </a:defRPr>
-            </a:pPr>
-            <a:r>
-              <a:t>• [ ] Integrasikan ke CI/CD: go test ./... atau custom binary di PR gate.</a:t>
-            </a:r>
-          </a:p>
-          <a:p>
-            <a:pPr>
-              <a:spcAft>
-                <a:spcPts val="400"/>
-              </a:spcAft>
-              <a:defRPr sz="1200">
-                <a:solidFill>
-                  <a:srgbClr val="0B1B2D"/>
-                </a:solidFill>
-              </a:defRPr>
-            </a:pPr>
-            <a:r>
-              <a:t>• [ ] Dokumentasikan policy tim: setiap perubahan keputusan wajib ADR baru, bukan edit retroaktif.</a:t>
+              <a:t>• [ ] Larang edit retroaktif: keputusan baru wajib nomor ADR baru.</a:t>
             </a:r>
           </a:p>
         </p:txBody>
@@ -11904,7 +11203,7 @@
               </a:defRPr>
             </a:pPr>
             <a:r>
-              <a:t>Implementasi ADR linter di lingkungan production memerlukan enam langkah praktis. Dimulai dari definisi template Markdown standar yang disepakati tim, dilanjutkan implementasi parser dan linter sesuai pola yang divalidasi di lab. Integrasi CI/CD memastikan violation langsung ditolak pada PR. Langkah terakhir — yang paling sering terlewat — adalah policy enforcement: mengubah budaya tim agar setiap perubahan keputusan arsitektur dicatat sebagai ADR baru, bukan suntingan retroaktif pada ADR lama.</a:t>
+              <a:t>Implementasi sukses menggabungkan template terstandar dan CI gate otomatis. Aturan terpenting: jangan ubah ADR lama secara retroaktif; buat catatan baru jika arah berubah.</a:t>
             </a:r>
           </a:p>
         </p:txBody>
@@ -11956,7 +11255,7 @@
               </a:defRPr>
             </a:pPr>
             <a:r>
-              <a:t>Checklist ensures consistent adoption; culture change ensures sustained compliance.</a:t>
+              <a:t>Pair clear Markdown standards with automated CI gates to prevent drift.</a:t>
             </a:r>
           </a:p>
         </p:txBody>
@@ -11991,7 +11290,7 @@
               </a:defRPr>
             </a:pPr>
             <a:r>
-              <a:t>labs/17-architecture-decision-record/engineering/02-implementation-notes.md</a:t>
+              <a:t>engineering/02-implementation-notes.md</a:t>
             </a:r>
           </a:p>
         </p:txBody>
@@ -12157,7 +11456,7 @@
               </a:defRPr>
             </a:pPr>
             <a:r>
-              <a:t>Anti-Pattern: 5 Kebiasaan Buruk Saat Mengadopsi ADR</a:t>
+              <a:t>Anti-Pattern: Kesalahan Adopsi ADR</a:t>
             </a:r>
           </a:p>
         </p:txBody>
@@ -12192,7 +11491,7 @@
               </a:defRPr>
             </a:pPr>
             <a:r>
-              <a:t>Kesalahan umum yang mengurangi efektivitas ADR dan cara menghindarinya.</a:t>
+              <a:t>Kebiasaan buruk yang merusak manfaat catatan keputusan arsitektur.</a:t>
             </a:r>
           </a:p>
         </p:txBody>
@@ -12227,7 +11526,7 @@
               </a:defRPr>
             </a:pPr>
             <a:r>
-              <a:t>ANTI-PATTERN SERING TERJADI</a:t>
+              <a:t>HINDARI POLA INI</a:t>
             </a:r>
           </a:p>
           <a:p>
@@ -12242,7 +11541,7 @@
               </a:defRPr>
             </a:pPr>
             <a:r>
-              <a:t>Mengklik ADR untuk segala hal: refactor kecil, penamaan variabel → noise berlebihan.</a:t>
+              <a:t>• Menulis ADR untuk hal sepele seperti penamaan variabel.</a:t>
             </a:r>
           </a:p>
           <a:p>
@@ -12257,7 +11556,7 @@
               </a:defRPr>
             </a:pPr>
             <a:r>
-              <a:t>• Mengedit ADR yang sudah Accepted secara silent, tanpa membuat ADR baru (retroactive edit).</a:t>
+              <a:t>• Mengedit ADR Accepted diam-diam alih-alih membuat pengganti.</a:t>
             </a:r>
           </a:p>
           <a:p>
@@ -12272,7 +11571,7 @@
               </a:defRPr>
             </a:pPr>
             <a:r>
-              <a:t>• Menulis ADR hanya sebagai catatan meeting tanpa section Decision yang eksplisit.</a:t>
+              <a:t>• Membiarkan status Draft berbulan-bulan tanpa kejelasan.</a:t>
             </a:r>
           </a:p>
           <a:p>
@@ -12287,22 +11586,7 @@
               </a:defRPr>
             </a:pPr>
             <a:r>
-              <a:t>• Status 'Draft' bertahan terlalu lama tanpa transisi ke Accepted atau Rejected.</a:t>
-            </a:r>
-          </a:p>
-          <a:p>
-            <a:pPr>
-              <a:spcAft>
-                <a:spcPts val="400"/>
-              </a:spcAft>
-              <a:defRPr sz="1200">
-                <a:solidFill>
-                  <a:srgbClr val="0B1B2D"/>
-                </a:solidFill>
-              </a:defRPr>
-            </a:pPr>
-            <a:r>
-              <a:t>• Melupakan update SupersededBy pada ADR lama saat ADR baru dibuat.</a:t>
+              <a:t>• Lupa mencatat nomor ADR pengganti saat membuat keputusan baru.</a:t>
             </a:r>
           </a:p>
         </p:txBody>
@@ -12340,7 +11624,7 @@
               </a:defRPr>
             </a:pPr>
             <a:r>
-              <a:t> Lima anti-pattern ini sering muncul saat tim pertama kali mengadopsi ADR. Pola yang paling merusak adalah retroactive edit — suntingan diametral pada ADR yang sudah Accepted. Ini menghancurkan jejak keputusan dan membuat engineer berikutnya membaca konteks yang sudah tidak relevan. ADR linter lab ini dirancang untuk mencegah sebagian besar anti-pattern tersebut secara struktural, meskipun tidak menutupi masalah adopsi budaya tim.</a:t>
+              <a:t>Anti-pattern paling berbahaya adalah suntingan diam-diam pada keputusan lama. Hal ini menghapus riwayat pembelajaran tim dan memicu asumsi keliru bagi engineer baru.</a:t>
             </a:r>
           </a:p>
         </p:txBody>
@@ -12392,7 +11676,7 @@
               </a:defRPr>
             </a:pPr>
             <a:r>
-              <a:t>ADR anti-patterns are cultural; linter catches structural symptoms, not behavioral roots.</a:t>
+              <a:t>Never overwrite historical decisions; publish a new record to maintain lineage.</a:t>
             </a:r>
           </a:p>
         </p:txBody>
@@ -12427,7 +11711,7 @@
               </a:defRPr>
             </a:pPr>
             <a:r>
-              <a:t>labs/17-architecture-decision-record/content/02-master-draft.md</a:t>
+              <a:t>content/02-master-draft.md</a:t>
             </a:r>
           </a:p>
         </p:txBody>
@@ -12593,7 +11877,7 @@
               </a:defRPr>
             </a:pPr>
             <a:r>
-              <a:t>Reproduksi Mandiri: Jalankan Demo dan Test di Lokal</a:t>
+              <a:t>Reproduksi Mandiri di Mesin Lokal</a:t>
             </a:r>
           </a:p>
         </p:txBody>
@@ -12628,7 +11912,7 @@
               </a:defRPr>
             </a:pPr>
             <a:r>
-              <a:t>Semua dependency menggunakan Go standard library, tanpa framework eksternal.</a:t>
+              <a:t>Eksperimen dijalankan dengan Go standard library tanpa dependency luar.</a:t>
             </a:r>
           </a:p>
         </p:txBody>
@@ -12685,15 +11969,15 @@
             </a:r>
             <a:br/>
             <a:r>
-              <a:t>go test -v ./...</a:t>
+              <a:t>go test -v ./...    # validasi parser &amp; linter</a:t>
             </a:r>
             <a:br/>
             <a:r>
-              <a:t>go test -race ./...</a:t>
+              <a:t>go test -race ./... # cek race condition</a:t>
             </a:r>
             <a:br/>
             <a:r>
-              <a:t>go run ./cmd/demo</a:t>
+              <a:t>go run ./cmd/demo   # jalankan simulasi 3 ADR</a:t>
             </a:r>
           </a:p>
         </p:txBody>
@@ -12731,7 +12015,7 @@
               </a:defRPr>
             </a:pPr>
             <a:r>
-              <a:t>Laboratorium ini dirancang untuk reproduksi instan di mesin manapun yang menjalankan Go 1.22+. Tidak ada dependensi eksternal, tidak ada database, tidak ada network call. Command go run ./cmd/demo menjalankan demo CLI yang memuat tiga ADR dari string literal, mem-parsenya, dan menjalankan linter. Command go test -race memastikan tidak ada race condition pada konkurensi linter. Seluruh artefak testing dan catatan audit tersedia di direktori lab untuk studi lebih lanjut.</a:t>
+              <a:t>Lab ini zero-dependency dan dapat direproduksi langsung. Menjalankan demo dan test membuktikan parser dan linter bekerja secara mandiri di lokal.</a:t>
             </a:r>
           </a:p>
         </p:txBody>
@@ -12783,7 +12067,7 @@
               </a:defRPr>
             </a:pPr>
             <a:r>
-              <a:t>Zero-dependency Go standard library ensures instant reproduction on any machine.</a:t>
+              <a:t>Zero-dependency tests ensure fast, repeatable verification on any developer machine.</a:t>
             </a:r>
           </a:p>
         </p:txBody>
@@ -12984,7 +12268,7 @@
               </a:defRPr>
             </a:pPr>
             <a:r>
-              <a:t>ADR Diubah Jadi Data yang Bisa Dicek, Bukan Hanya Dokumen</a:t>
+              <a:t>ADR Diubah Jadi Data yang Bisa Dicek</a:t>
             </a:r>
           </a:p>
         </p:txBody>
@@ -13019,7 +12303,7 @@
               </a:defRPr>
             </a:pPr>
             <a:r>
-              <a:t>Parser+linter memindahkan keputusan arsitektur dari domain narasi ke domain struktur terverifikasi.</a:t>
+              <a:t>Memindahkan keputusan arsitektur dari teks bebas ke struktur yang terverifikasi.</a:t>
             </a:r>
           </a:p>
         </p:txBody>
@@ -13054,7 +12338,7 @@
               </a:defRPr>
             </a:pPr>
             <a:r>
-              <a:t>PELAJARAN REKAYASA</a:t>
+              <a:t>PRINSIP REKAYASA</a:t>
             </a:r>
           </a:p>
           <a:p>
@@ -13069,7 +12353,7 @@
               </a:defRPr>
             </a:pPr>
             <a:r>
-              <a:t>• ADR yang diparse menjadi struct Record memungkinkan validasi otomatis yang tidak bisa dilakukan humans dengan andal.</a:t>
+              <a:t>• ADR terstruktur memungkinkan verifikasi otomatis relasi dokumen.</a:t>
             </a:r>
           </a:p>
           <a:p>
@@ -13084,7 +12368,7 @@
               </a:defRPr>
             </a:pPr>
             <a:r>
-              <a:t>• Bidirectional supersession link adalah invarian yang paling sering rusak; linter menangkapnya di detik pertama.</a:t>
+              <a:t>• Linter menutup kelalaian mekanis yang sering luput dari review manusia.</a:t>
             </a:r>
           </a:p>
           <a:p>
@@ -13099,21 +12383,6 @@
               </a:defRPr>
             </a:pPr>
             <a:r>
-              <a:t>• Konkurensi goroutine + mutex pattern untuk error aggregation adalah reusable pattern untuk validation framework lain.</a:t>
-            </a:r>
-          </a:p>
-          <a:p>
-            <a:pPr>
-              <a:spcAft>
-                <a:spcPts val="400"/>
-              </a:spcAft>
-              <a:defRPr sz="1200">
-                <a:solidFill>
-                  <a:srgbClr val="0B1B2D"/>
-                </a:solidFill>
-              </a:defRPr>
-            </a:pPr>
-            <a:r>
               <a:t>• Format standar membantu review; kualitas keputusan tetap ditentukan isi ADR.</a:t>
             </a:r>
           </a:p>
@@ -13152,7 +12421,7 @@
               </a:defRPr>
             </a:pPr>
             <a:r>
-              <a:t>Pelajaran rekayasa perangkat lunak utama dari lab ini adalah pergeseran perspektif: dari ADR sebagai dokumen naratif statis menjadi ADR sebagai record terstruktur yang dapat diverifikasi mesin. Parser dan linter tidak menggantikan judgment arsitek, tetapi mereka menutupi gap mekanisme yang konsisten terlewat oleh review manual. Pola validasi konkuren yang diterapkan di linter juga bersifat generik dan dapat diadaptasi untuk validasi dokumen struktural lain di luar konteks ADR.</a:t>
+              <a:t>Nilai utama lab ini adalah menjadikan keputusan arsitektur sebagai data yang bisa diuji. Linter menjaga integritas silsilah dokumen, sementara manusia fokus pada kualitas keputusan.</a:t>
             </a:r>
           </a:p>
         </p:txBody>
@@ -13204,7 +12473,7 @@
               </a:defRPr>
             </a:pPr>
             <a:r>
-              <a:t>Structured validation catches what human review consistently misses: mechanical relation gaps.</a:t>
+              <a:t>Parser makes ADR structured; linter enforces rules. Decisions remain human.</a:t>
             </a:r>
           </a:p>
         </p:txBody>
@@ -13239,7 +12508,7 @@
               </a:defRPr>
             </a:pPr>
             <a:r>
-              <a:t>labs/17-architecture-decision-record/content/05-key-takeaways.md</a:t>
+              <a:t>content/05-key-takeaways.md</a:t>
             </a:r>
           </a:p>
         </p:txBody>
@@ -13785,7 +13054,7 @@
               </a:defRPr>
             </a:pPr>
             <a:r>
-              <a:t>Review Markdown Manual Lupa Relasi Penggantian</a:t>
+              <a:t>Review Manual Melewatkan Relasi Supersesi</a:t>
             </a:r>
           </a:p>
         </p:txBody>
@@ -13820,7 +13089,7 @@
               </a:defRPr>
             </a:pPr>
             <a:r>
-              <a:t>Engineer bisa saja update isi ADR lama tapi lupa tambahkan tautan supersesi ke ADR baru.</a:t>
+              <a:t>Reviewer manusia fokus pada isi teks, tetapi melewatkan sinkronisasi tautan dokumen.</a:t>
             </a:r>
           </a:p>
         </p:txBody>
@@ -13870,7 +13139,7 @@
               </a:defRPr>
             </a:pPr>
             <a:r>
-              <a:t>• ADR 1 tetap berstatus 'Accepted' padahal sudah diganti ADR 2 — lupa di-update.</a:t>
+              <a:t>• ADR baru menyatakan menggantikan ADR lama, tetapi ADR lama tidak diubah.</a:t>
             </a:r>
           </a:p>
           <a:p>
@@ -13885,7 +13154,7 @@
               </a:defRPr>
             </a:pPr>
             <a:r>
-              <a:t>• ADR 2 menulis 'Supersedes: 1', tapi ADR 1 tidak pernah dicatat 'Superseded by 2'.</a:t>
+              <a:t>• ADR lama tetap bertanda aktif padahal keputusannya sudah ditinggalkan.</a:t>
             </a:r>
           </a:p>
           <a:p>
@@ -13900,49 +13169,7 @@
               </a:defRPr>
             </a:pPr>
             <a:r>
-              <a:t>• Penomoran loncat: ADR 1, ADR 3 langsung — engineer lupa insert ADR 2.</a:t>
-            </a:r>
-          </a:p>
-          <a:p>
-            <a:pPr>
-              <a:spcAft>
-                <a:spcPts val="400"/>
-              </a:spcAft>
-              <a:defRPr sz="1200">
-                <a:solidFill>
-                  <a:srgbClr val="0B1B2D"/>
-                </a:solidFill>
-              </a:defRPr>
-            </a:pPr>
-            <a:r>
-              <a:t>• Status informal seperti 'Draft', 'In Review' diterima tanpa penolakan.</a:t>
-            </a:r>
-          </a:p>
-          <a:p>
-            <a:pPr>
-              <a:defRPr sz="1200" b="1">
-                <a:solidFill>
-                  <a:srgbClr val="087F76"/>
-                </a:solidFill>
-              </a:defRPr>
-            </a:pPr>
-            <a:r>
-              <a:t>CONTOH KASUS NYATA</a:t>
-            </a:r>
-          </a:p>
-          <a:p>
-            <a:pPr>
-              <a:spcAft>
-                <a:spcPts val="400"/>
-              </a:spcAft>
-              <a:defRPr sz="1200">
-                <a:solidFill>
-                  <a:srgbClr val="0B1B2D"/>
-                </a:solidFill>
-              </a:defRPr>
-            </a:pPr>
-            <a:r>
-              <a:t>• ADR 1 ber-status Superseded by 99, padahal ADR 99 belum pernah dibuat.</a:t>
+              <a:t>• Tautan referensi menunjuk ke nomor yang salah tanpa disadari.</a:t>
             </a:r>
           </a:p>
         </p:txBody>
@@ -13980,7 +13207,7 @@
               </a:defRPr>
             </a:pPr>
             <a:r>
-              <a:t>Ketika tim mengandalkan review manual terhadap dokumen Markdown ADR, pola kegagalan yang paling sering muncul adalah tautan supersesi yang tidak sinkron. Engineer bisa jadi memperbarui isi keputusan pada ADR baru namun lupa mengembalikan marker pada ADR lama. Atau sebaliknya: ADR baru mengklanimsupersedes_ADR lama, tapi ADR lama tidak pernah mengubah statusnya menjadi Superseded. Review manual juga sulit mendeteksi loncatan nomor urut karena tidak ada mekanisme enforcement struktural.</a:t>
+              <a:t>Masalah terbesar review manual adalah supersesi yang tidak sinkron. ADR baru mengklaim menggantikan, tetapi ADR lama tetap bertanda aktif karena lupa diperbarui.</a:t>
             </a:r>
           </a:p>
         </p:txBody>
@@ -14032,7 +13259,7 @@
               </a:defRPr>
             </a:pPr>
             <a:r>
-              <a:t>Manual review catches content errors but misses structural relation gaps.</a:t>
+              <a:t>Manual review catches content typos but misses broken relationship links.</a:t>
             </a:r>
           </a:p>
         </p:txBody>
@@ -14067,7 +13294,7 @@
               </a:defRPr>
             </a:pPr>
             <a:r>
-              <a:t>labs/17-architecture-decision-record/content/02-master-draft.md</a:t>
+              <a:t>content/02-master-draft.md</a:t>
             </a:r>
           </a:p>
         </p:txBody>
@@ -14233,7 +13460,7 @@
               </a:defRPr>
             </a:pPr>
             <a:r>
-              <a:t>ADR Bukan Dokumen, Tapi Record yang Bisa Dicek</a:t>
+              <a:t>ADR Bukan Dokumen, Tapi Record</a:t>
             </a:r>
           </a:p>
         </p:txBody>
@@ -14268,7 +13495,7 @@
               </a:defRPr>
             </a:pPr>
             <a:r>
-              <a:t>Parser mengubah baris Markdown menjadi struct Record; linter memeriksa aturan struktural.</a:t>
+              <a:t>Parser memindahkan Markdown ke data terstruktur agar aturan bisa diperiksa mesin.</a:t>
             </a:r>
           </a:p>
         </p:txBody>
@@ -14303,7 +13530,7 @@
               </a:defRPr>
             </a:pPr>
             <a:r>
-              <a:t>PRINSIP PENTING</a:t>
+              <a:t>PRINSIP INTI</a:t>
             </a:r>
           </a:p>
           <a:p>
@@ -14318,7 +13545,7 @@
               </a:defRPr>
             </a:pPr>
             <a:r>
-              <a:t>• ADR diolah sebagai data, bukan sekadar teks human-readable.</a:t>
+              <a:t>• ADR diperlakukan sebagai data terstruktur, bukan sekadar teks bebas.</a:t>
             </a:r>
           </a:p>
           <a:p>
@@ -14333,7 +13560,7 @@
               </a:defRPr>
             </a:pPr>
             <a:r>
-              <a:t>• Parser mengekstrak ID, Title, Status, SupersededBy, Supersedes, Content.</a:t>
+              <a:t>• Field kunci diekstrak: ID, Judul, Status, SupersededBy, dan Supersedes.</a:t>
             </a:r>
           </a:p>
           <a:p>
@@ -14348,22 +13575,7 @@
               </a:defRPr>
             </a:pPr>
             <a:r>
-              <a:t>• Linter memvalidasi aturan: monotonik ID, valid status, relasi timbal-balik.</a:t>
-            </a:r>
-          </a:p>
-          <a:p>
-            <a:pPr>
-              <a:spcAft>
-                <a:spcPts val="400"/>
-              </a:spcAft>
-              <a:defRPr sz="1200">
-                <a:solidFill>
-                  <a:srgbClr val="0B1B2D"/>
-                </a:solidFill>
-              </a:defRPr>
-            </a:pPr>
-            <a:r>
-              <a:t>• Keputusan arsitektur tetap ditulis manusiawi; mesin hanya memeriksa format.</a:t>
+              <a:t>• Mesin memvalidasi konsistensi; manusia tetap menulis esensi keputusannya.</a:t>
             </a:r>
           </a:p>
         </p:txBody>
@@ -14401,7 +13613,7 @@
               </a:defRPr>
             </a:pPr>
             <a:r>
-              <a:t>Inti dari pendekatan lab ini adalah memandang Architecture Decision Record bukan sebagai dokumen naratif yang perlu dibaca manusia secara manual, melainkan sebagai record terstruktur yang bisa diparse dan divalidasi oleh mesin. Parser membaca Markdown, mengekstrak field-field kunci menjadi struct Record, dan linter kemudian menjalankan serangkaian aturan struktural. Nilai utama bukan pada otomasi pengambilan keputusan, melainkan pada kemampuan mendeteksi anomali struktural yang sering luput dari review manual.</a:t>
+              <a:t>ADR bukan sekadar dokumen naratif. Saat diubah menjadi struct Record, mesin bisa mengekstrak field kunci dan memeriksa konsistensi yang sering terlewat oleh manusia.</a:t>
             </a:r>
           </a:p>
         </p:txBody>
@@ -14453,7 +13665,7 @@
               </a:defRPr>
             </a:pPr>
             <a:r>
-              <a:t>ADR is structured data first, human narrative second; validation catches what humans miss.</a:t>
+              <a:t>ADR is structured data first, human narrative second.</a:t>
             </a:r>
           </a:p>
         </p:txBody>
@@ -14488,7 +13700,7 @@
               </a:defRPr>
             </a:pPr>
             <a:r>
-              <a:t>labs/17-architecture-decision-record/internal/adr/models.go • internal/adr/parser.go</a:t>
+              <a:t>internal/adr/models.go</a:t>
             </a:r>
           </a:p>
         </p:txBody>
@@ -14654,7 +13866,7 @@
               </a:defRPr>
             </a:pPr>
             <a:r>
-              <a:t>Pipeline: Markdown → Parser → Records → Linter</a:t>
+              <a:t>Pipeline Validasi Empat Tahap</a:t>
             </a:r>
           </a:p>
         </p:txBody>
@@ -14689,7 +13901,7 @@
               </a:defRPr>
             </a:pPr>
             <a:r>
-              <a:t>Alur konversi ADR dari teks bebas menjadi record terstruktur dan validasi paralel.</a:t>
+              <a:t>Alur konversi dokumen ADR dari teks mentah hingga laporan integritas.</a:t>
             </a:r>
           </a:p>
         </p:txBody>
@@ -14724,7 +13936,7 @@
               </a:defRPr>
             </a:pPr>
             <a:r>
-              <a:t>ARCHITECTURE FLOW</a:t>
+              <a:t>VALIDATION PIPELINE</a:t>
             </a:r>
           </a:p>
           <a:p>
@@ -14739,7 +13951,7 @@
               </a:defRPr>
             </a:pPr>
             <a:r>
-              <a:t>[Markdown ADR Text] → adr.Parser (Regex extraction: ID, Title, Status, refs)</a:t>
+              <a:t>Markdown Files → adr.Parser (ekstraksi field &amp; status)</a:t>
             </a:r>
           </a:p>
           <a:p>
@@ -14754,7 +13966,7 @@
               </a:defRPr>
             </a:pPr>
             <a:r>
-              <a:t>→ []*adr.Record (In-Memory Structs)</a:t>
+              <a:t>→ []*adr.Record (in-memory struct)</a:t>
             </a:r>
           </a:p>
           <a:p>
@@ -14769,7 +13981,7 @@
               </a:defRPr>
             </a:pPr>
             <a:r>
-              <a:t>→ adr.Linter.Validate(records)</a:t>
+              <a:t>→ adr.Linter (cek urutan ID, siklus, &amp; relasi timbal-balik)</a:t>
             </a:r>
           </a:p>
           <a:p>
@@ -14784,52 +13996,7 @@
               </a:defRPr>
             </a:pPr>
             <a:r>
-              <a:t>•   ├─ Monotonic numbering check: sort + sequential scan</a:t>
-            </a:r>
-          </a:p>
-          <a:p>
-            <a:pPr>
-              <a:spcAft>
-                <a:spcPts val="400"/>
-              </a:spcAft>
-              <a:defRPr sz="1200">
-                <a:solidFill>
-                  <a:srgbClr val="0B1B2D"/>
-                </a:solidFill>
-              </a:defRPr>
-            </a:pPr>
-            <a:r>
-              <a:t>•   ├─ Cycle detection: DFS with visiting/visited states</a:t>
-            </a:r>
-          </a:p>
-          <a:p>
-            <a:pPr>
-              <a:spcAft>
-                <a:spcPts val="400"/>
-              </a:spcAft>
-              <a:defRPr sz="1200">
-                <a:solidFill>
-                  <a:srgbClr val="0B1B2D"/>
-                </a:solidFill>
-              </a:defRPr>
-            </a:pPr>
-            <a:r>
-              <a:t>•   └─ Bidirectional lineage: goroutines + sync.Mutex per-record validation</a:t>
-            </a:r>
-          </a:p>
-          <a:p>
-            <a:pPr>
-              <a:spcAft>
-                <a:spcPts val="400"/>
-              </a:spcAft>
-              <a:defRPr sz="1200">
-                <a:solidFill>
-                  <a:srgbClr val="0B1B2D"/>
-                </a:solidFill>
-              </a:defRPr>
-            </a:pPr>
-            <a:r>
-              <a:t>→ []error (empty = valid, non-empty = integrity breach)</a:t>
+              <a:t>→ []error (laporan pelanggaran integritas)</a:t>
             </a:r>
           </a:p>
         </p:txBody>
@@ -14867,7 +14034,7 @@
               </a:defRPr>
             </a:pPr>
             <a:r>
-              <a:t>Arsitektur sistem validasi ADR pada lab ini dibangun sebagai pipeline tiga tahap. Tahap pertama, parser membaca Markdown baris demi baris menggunakan regex dan mengekstrak field-field kunci. Hasilnya adalah slice struct Record yang berisi metadata keputusan. Tahap kedua, linter menjalankan validasi urutan ID monotonik dan deteksi siklus melalui depth-first search. Tahap ketiga, validasi graf silsilah dilakukan secara paralel menggunakan goroutine dengan mutex untuk agregasi error, memastikan setiap tautan SupersededBy dan Supersedes saling konsisten.</a:t>
+              <a:t>Pipeline-nya sederhana: Markdown dibaca, field penting diekstrak, lalu linter memeriksa aturan graf.</a:t>
             </a:r>
           </a:p>
         </p:txBody>
@@ -14919,7 +14086,7 @@
               </a:defRPr>
             </a:pPr>
             <a:r>
-              <a:t>Pipeline separates parsing from validation: each stage has a single responsibility.</a:t>
+              <a:t>Separate parsing from validation: simple stages create reliable checks.</a:t>
             </a:r>
           </a:p>
         </p:txBody>
@@ -15120,7 +14287,7 @@
               </a:defRPr>
             </a:pPr>
             <a:r>
-              <a:t>Struct Record: Definisi Inti ADR</a:t>
+              <a:t>Struct Record: Fondasi Validasi Data</a:t>
             </a:r>
           </a:p>
         </p:txBody>
@@ -15155,7 +14322,7 @@
               </a:defRPr>
             </a:pPr>
             <a:r>
-              <a:t>Lima field wajib membuat setiap keputusan arsitektur dapat direferensikan dan diverifikasi.</a:t>
+              <a:t>Field eksplisit membuat relasi antar-keputusan dapat diperiksa programmatically.</a:t>
             </a:r>
           </a:p>
         </p:txBody>
@@ -15208,61 +14375,27 @@
               </a:defRPr>
             </a:pPr>
             <a:r>
-              <a:t>type Status string</a:t>
+              <a:t>type Record struct {</a:t>
             </a:r>
             <a:br/>
+            <a:r>
+              <a:t>    ID           int</a:t>
+            </a:r>
             <a:br/>
             <a:r>
-              <a:t>const (</a:t>
+              <a:t>    Title        string</a:t>
             </a:r>
             <a:br/>
             <a:r>
-              <a:t>    StatusProposed   Status = "Proposed"</a:t>
+              <a:t>    Status       Status</a:t>
             </a:r>
             <a:br/>
             <a:r>
-              <a:t>    StatusAccepted   Status = "Accepted"</a:t>
+              <a:t>    SupersededBy int // 0 jika aktif</a:t>
             </a:r>
             <a:br/>
             <a:r>
-              <a:t>    StatusSuperseded Status = "Superseded"</a:t>
-            </a:r>
-            <a:br/>
-            <a:r>
-              <a:t>    StatusDeprecated Status = "Deprecated"</a:t>
-            </a:r>
-            <a:br/>
-            <a:r>
-              <a:t>    StatusRejected   Status = "Rejected"</a:t>
-            </a:r>
-            <a:br/>
-            <a:r>
-              <a:t>)</a:t>
-            </a:r>
-            <a:br/>
-            <a:br/>
-            <a:r>
-              <a:t>type Record struct {</a:t>
-            </a:r>
-            <a:br/>
-            <a:r>
-              <a:t>    ID           int</a:t>
-            </a:r>
-            <a:br/>
-            <a:r>
-              <a:t>    Title        string</a:t>
-            </a:r>
-            <a:br/>
-            <a:r>
-              <a:t>    Status       Status</a:t>
-            </a:r>
-            <a:br/>
-            <a:r>
-              <a:t>    SupersededBy int // 0 if not superseded</a:t>
-            </a:r>
-            <a:br/>
-            <a:r>
-              <a:t>    Supersedes   int // 0 if does not supersede</a:t>
+              <a:t>    Supersedes   int // 0 jika tidak menggantikan</a:t>
             </a:r>
             <a:br/>
             <a:r>
@@ -15308,7 +14441,7 @@
               </a:defRPr>
             </a:pPr>
             <a:r>
-              <a:t>Struktur data Record pada models.go merupakan fondasi seluruh sistem validasi. Field Status menggunakan enum string yang hanya mengakui lima nilai resmi: Proposed, Accepted, Superseded, Deprecated, dan Rejected. Field SupersededBy mereferensikan ADR pengganti, sedangkan Supersedes mereferensikan ADR yang digantikan. Keduanya bernilai 0 (nol) ketika tidak ada relasi. Dengan representasi terstruktur ini, linter tidak perlu menebak-tebak — ia hanya memeriksa konsistensi integer dan string.</a:t>
+              <a:t>Struct Record mendefinisikan field wajib secara eksplisit. Dengan representasi integer dan enum, linter memeriksa aturan tanpa perlu menebak teks bebas.</a:t>
             </a:r>
           </a:p>
         </p:txBody>
@@ -15360,7 +14493,7 @@
               </a:defRPr>
             </a:pPr>
             <a:r>
-              <a:t>Explicit fields over implicit conventions make structural validation possible.</a:t>
+              <a:t>Explicit fields over implicit conventions enable automated linting.</a:t>
             </a:r>
           </a:p>
         </p:txBody>
@@ -15561,7 +14694,7 @@
               </a:defRPr>
             </a:pPr>
             <a:r>
-              <a:t>Supersesi Patah: ADR 1 Merujuk ke ADR 99</a:t>
+              <a:t>Deteksi Tautan Supersesi Patah</a:t>
             </a:r>
           </a:p>
         </p:txBody>
@@ -15596,7 +14729,7 @@
               </a:defRPr>
             </a:pPr>
             <a:r>
-              <a:t>Tautan Superseded by menunjuk ke nomor yang tidak ada — linter langsung menandai error.</a:t>
+              <a:t>Linter langsung menolak referensi yang menunjuk ke nomor ADR yang tidak ada.</a:t>
             </a:r>
           </a:p>
         </p:txBody>
@@ -15649,28 +14782,20 @@
               </a:defRPr>
             </a:pPr>
             <a:r>
-              <a:t>superseded points to non-existent:</a:t>
+              <a:t>ADR 1: Status Superseded by 99</a:t>
             </a:r>
             <a:br/>
             <a:r>
-              <a:t>  ADR 1: Status Superseded by 99</a:t>
-            </a:r>
-            <a:br/>
-            <a:r>
-              <a:t>  → Error: superseded by non-existent ADR 99</a:t>
+              <a:t>→ Error: superseded by non-existent ADR 99</a:t>
             </a:r>
             <a:br/>
             <a:br/>
             <a:r>
-              <a:t>supersedes points to non-existent:</a:t>
+              <a:t>ADR 1: Status Accepted, Supersedes: 99</a:t>
             </a:r>
             <a:br/>
             <a:r>
-              <a:t>  ADR 1: Status Accepted, Supersedes: 99</a:t>
-            </a:r>
-            <a:br/>
-            <a:r>
-              <a:t>  → Error: supersedes non-existent ADR 99</a:t>
+              <a:t>→ Error: supersedes non-existent ADR 99</a:t>
             </a:r>
           </a:p>
         </p:txBody>
@@ -15708,7 +14833,7 @@
               </a:defRPr>
             </a:pPr>
             <a:r>
-              <a:t>Skenario kegagalan paling umum pada pemeliharaan ADR manual adalah tautan supersesi yang merujuk ke nomor ADR yang belum ada atau sudah dihapus. Linter menangkap kasus ini dengan memverifikasi keberadaan setiap ID referensi di dalam recordMap. Jika ADR 1 menyatakan Superseded by 99 namun tidak ada Record dengan ID 99, pesan error spesifik langsung dihasilkan. Bukti ini berasal dari test case TestLinter_BrokenReferences yang dijalankan secara deterministik.</a:t>
+              <a:t>Linter memeriksa keberadaan setiap ID referensi. Jika ADR merujuk ke nomor yang belum ada, error spesifik langsung dihasilkan sebelum merger.</a:t>
             </a:r>
           </a:p>
         </p:txBody>
@@ -15760,7 +14885,7 @@
               </a:defRPr>
             </a:pPr>
             <a:r>
-              <a:t>A dangling reference is cheaper to catch at lint time than during an architectural review.</a:t>
+              <a:t>Dangling references are cheaper to catch at lint time than during incident review.</a:t>
             </a:r>
           </a:p>
         </p:txBody>
@@ -15961,7 +15086,7 @@
               </a:defRPr>
             </a:pPr>
             <a:r>
-              <a:t>Biaya Tersembunyi: Lineage Drift Tanpa Deteksi</a:t>
+              <a:t>Biaya Tersembunyi: Lineage Drift Menumpuk</a:t>
             </a:r>
           </a:p>
         </p:txBody>
@@ -15996,7 +15121,7 @@
               </a:defRPr>
             </a:pPr>
             <a:r>
-              <a:t>Setiap ADR baru yang tidak mengikuti aturan relasi meningkatkan kerumunan manual review.</a:t>
+              <a:t>Ketiadaan linter tidak merusak build, tetapi merusak keputusan masa depan.</a:t>
             </a:r>
           </a:p>
         </p:txBody>
@@ -16011,7 +15136,7 @@
         </p:nvGraphicFramePr>
         <p:xfrm>
           <a:off x="731520" y="1828800"/>
-          <a:ext cx="5120640" cy="2286000"/>
+          <a:ext cx="5120640" cy="1828800"/>
         </p:xfrm>
         <a:graphic>
           <a:graphicData uri="http://schemas.openxmlformats.org/drawingml/2006/table">
@@ -16038,7 +15163,7 @@
                         </a:defRPr>
                       </a:pPr>
                       <a:r>
-                        <a:t>Time to detect</a:t>
+                        <a:t>Tahap</a:t>
                       </a:r>
                     </a:p>
                   </a:txBody>
@@ -16061,7 +15186,7 @@
                         </a:defRPr>
                       </a:pPr>
                       <a:r>
-                        <a:t>Cause</a:t>
+                        <a:t>Deteksi</a:t>
                       </a:r>
                     </a:p>
                   </a:txBody>
@@ -16084,7 +15209,7 @@
                         </a:defRPr>
                       </a:pPr>
                       <a:r>
-                        <a:t>Impact</a:t>
+                        <a:t>Dampak</a:t>
                       </a:r>
                     </a:p>
                   </a:txBody>
@@ -16109,7 +15234,7 @@
                         </a:defRPr>
                       </a:pPr>
                       <a:r>
-                        <a:t>Instant (CI)</a:t>
+                        <a:t>CI Gate</a:t>
                       </a:r>
                     </a:p>
                   </a:txBody>
@@ -16132,7 +15257,7 @@
                         </a:defRPr>
                       </a:pPr>
                       <a:r>
-                        <a:t>Linter reject di PR</a:t>
+                        <a:t>Seketika</a:t>
                       </a:r>
                     </a:p>
                   </a:txBody>
@@ -16155,7 +15280,7 @@
                         </a:defRPr>
                       </a:pPr>
                       <a:r>
-                        <a:t>Build gagal, engineer feedback loop cepat</a:t>
+                        <a:t>PR ditolak, feedback loop cepat</a:t>
                       </a:r>
                     </a:p>
                   </a:txBody>
@@ -16167,6 +15292,29 @@
                 </a:tc>
               </a:tr>
               <a:tr h="457200">
+                <a:tc>
+                  <a:txBody>
+                    <a:bodyPr/>
+                    <a:lstStyle/>
+                    <a:p>
+                      <a:pPr>
+                        <a:defRPr sz="1000">
+                          <a:solidFill>
+                            <a:srgbClr val="0B1B2D"/>
+                          </a:solidFill>
+                        </a:defRPr>
+                      </a:pPr>
+                      <a:r>
+                        <a:t>Review Manual</a:t>
+                      </a:r>
+                    </a:p>
+                  </a:txBody>
+                  <a:tcPr>
+                    <a:solidFill>
+                      <a:srgbClr val="FFFFFF"/>
+                    </a:solidFill>
+                  </a:tcPr>
+                </a:tc>
                 <a:tc>
                   <a:txBody>
                     <a:bodyPr/>
@@ -16203,30 +15351,7 @@
                         </a:defRPr>
                       </a:pPr>
                       <a:r>
-                        <a:t>Manual audit dokumentasi</a:t>
-                      </a:r>
-                    </a:p>
-                  </a:txBody>
-                  <a:tcPr>
-                    <a:solidFill>
-                      <a:srgbClr val="FFFFFF"/>
-                    </a:solidFill>
-                  </a:tcPr>
-                </a:tc>
-                <a:tc>
-                  <a:txBody>
-                    <a:bodyPr/>
-                    <a:lstStyle/>
-                    <a:p>
-                      <a:pPr>
-                        <a:defRPr sz="1000">
-                          <a:solidFill>
-                            <a:srgbClr val="0B1B2D"/>
-                          </a:solidFill>
-                        </a:defRPr>
-                      </a:pPr>
-                      <a:r>
-                        <a:t>Engineer kebingungan siapa yang aktif</a:t>
+                        <a:t>Tim bingung dokumen mana yang aktif</a:t>
                       </a:r>
                     </a:p>
                   </a:txBody>
@@ -16251,7 +15376,7 @@
                         </a:defRPr>
                       </a:pPr>
                       <a:r>
-                        <a:t>Bulanan</a:t>
+                        <a:t>Insiden Sistem</a:t>
                       </a:r>
                     </a:p>
                   </a:txBody>
@@ -16274,7 +15399,7 @@
                         </a:defRPr>
                       </a:pPr>
                       <a:r>
-                        <a:t>Production incident review</a:t>
+                        <a:t>Berbulan-bulan</a:t>
                       </a:r>
                     </a:p>
                   </a:txBody>
@@ -16297,78 +15422,7 @@
                         </a:defRPr>
                       </a:pPr>
                       <a:r>
-                        <a:t>Tim kehilangan konteks keputusan penting</a:t>
-                      </a:r>
-                    </a:p>
-                  </a:txBody>
-                  <a:tcPr>
-                    <a:solidFill>
-                      <a:srgbClr val="FFFFFF"/>
-                    </a:solidFill>
-                  </a:tcPr>
-                </a:tc>
-              </a:tr>
-              <a:tr h="457200">
-                <a:tc>
-                  <a:txBody>
-                    <a:bodyPr/>
-                    <a:lstStyle/>
-                    <a:p>
-                      <a:pPr>
-                        <a:defRPr sz="1000">
-                          <a:solidFill>
-                            <a:srgbClr val="0B1B2D"/>
-                          </a:solidFill>
-                        </a:defRPr>
-                      </a:pPr>
-                      <a:r>
-                        <a:t>Selamanya</a:t>
-                      </a:r>
-                    </a:p>
-                  </a:txBody>
-                  <a:tcPr>
-                    <a:solidFill>
-                      <a:srgbClr val="FFFFFF"/>
-                    </a:solidFill>
-                  </a:tcPr>
-                </a:tc>
-                <a:tc>
-                  <a:txBody>
-                    <a:bodyPr/>
-                    <a:lstStyle/>
-                    <a:p>
-                      <a:pPr>
-                        <a:defRPr sz="1000">
-                          <a:solidFill>
-                            <a:srgbClr val="0B1B2D"/>
-                          </a:solidFill>
-                        </a:defRPr>
-                      </a:pPr>
-                      <a:r>
-                        <a:t>Keputusan salah diterapkan</a:t>
-                      </a:r>
-                    </a:p>
-                  </a:txBody>
-                  <a:tcPr>
-                    <a:solidFill>
-                      <a:srgbClr val="FFFFFF"/>
-                    </a:solidFill>
-                  </a:tcPr>
-                </a:tc>
-                <a:tc>
-                  <a:txBody>
-                    <a:bodyPr/>
-                    <a:lstStyle/>
-                    <a:p>
-                      <a:pPr>
-                        <a:defRPr sz="1000">
-                          <a:solidFill>
-                            <a:srgbClr val="0B1B2D"/>
-                          </a:solidFill>
-                        </a:defRPr>
-                      </a:pPr>
-                      <a:r>
-                        <a:t>Sistem berkembang dengan asumsi keliru</a:t>
+                        <a:t>Keputusan baru berpijak pada asumsi keliru</a:t>
                       </a:r>
                     </a:p>
                   </a:txBody>
@@ -16416,7 +15470,7 @@
               </a:defRPr>
             </a:pPr>
             <a:r>
-              <a:t>Biaya tersembunyi dari ketiadaan validasi otomatis bukan hanya waktu deteksi, tetapi akumulasi kepercayaan palsu bahwa dokumentasi ADR masih akurat. Setiap kali engineer menambahkan ADR baru tanpa memutakhirkan ADR lama, tercipta discrepancy yang hanya akan terdeteksi saat inspeksi manual. Pada tim kecil, hal ini mungkin tidak terasa. Namun begitu skala tim bertambah, waktu yang terbuang untuk mencari konsistensi manual berlipat ganda tanpa bound yang jelas.</a:t>
+              <a:t>Masalah ADR rusak bukan langsung terlihat. Ia menumpuk sampai keputusan baru bergantung pada catatan lama yang salah.</a:t>
             </a:r>
           </a:p>
         </p:txBody>
@@ -16468,7 +15522,7 @@
               </a:defRPr>
             </a:pPr>
             <a:r>
-              <a:t>Unverified lineage drift accumulates silently until a production decision depends on it.</a:t>
+              <a:t>Lineage drift accumulates silently until a new decision depends on stale records.</a:t>
             </a:r>
           </a:p>
         </p:txBody>
@@ -16503,7 +15557,7 @@
               </a:defRPr>
             </a:pPr>
             <a:r>
-              <a:t>labs/17-architecture-decision-record/content/02-master-draft.md</a:t>
+              <a:t>content/02-master-draft.md</a:t>
             </a:r>
           </a:p>
         </p:txBody>
@@ -16669,7 +15723,7 @@
               </a:defRPr>
             </a:pPr>
             <a:r>
-              <a:t>Setup Eksperimen: 3 ADR Evolusi Arsitektur</a:t>
+              <a:t>Skenario Demo: Tiga ADR Evolusi Arsitektur</a:t>
             </a:r>
           </a:p>
         </p:txBody>
@@ -16704,7 +15758,7 @@
               </a:defRPr>
             </a:pPr>
             <a:r>
-              <a:t>Demo memodelkan transisi dari Modular Monolith ke Microservice dengan satu ADR ditolak.</a:t>
+              <a:t>Memodelkan evolusi dari monolit ke microservice dengan satu usulan ditolak.</a:t>
             </a:r>
           </a:p>
         </p:txBody>
@@ -16739,7 +15793,7 @@
               </a:defRPr>
             </a:pPr>
             <a:r>
-              <a:t>ADR SEQUENCE</a:t>
+              <a:t>URUTAN KEPUTUSAN</a:t>
             </a:r>
           </a:p>
           <a:p>
@@ -16754,7 +15808,7 @@
               </a:defRPr>
             </a:pPr>
             <a:r>
-              <a:t>• ADR 0001: Use Modular Monolith for Core SaaS ERP | Status: Superseded by 2</a:t>
+              <a:t>• ADR 0001: Modular Monolith | Superseded by ADR 2</a:t>
             </a:r>
           </a:p>
           <a:p>
@@ -16769,7 +15823,7 @@
               </a:defRPr>
             </a:pPr>
             <a:r>
-              <a:t>• ADR 0002: Extract Notification Service to Microservice | Status: Accepted, Supersedes: 1</a:t>
+              <a:t>• ADR 0002: Notification Microservice | Accepted, Supersedes ADR 1</a:t>
             </a:r>
           </a:p>
           <a:p>
@@ -16784,52 +15838,7 @@
               </a:defRPr>
             </a:pPr>
             <a:r>
-              <a:t>• ADR 0003: Reject Event Sourcing for Order Management | Status: Rejected</a:t>
-            </a:r>
-          </a:p>
-          <a:p>
-            <a:pPr>
-              <a:spcAft>
-                <a:spcPts val="400"/>
-              </a:spcAft>
-              <a:defRPr sz="1200">
-                <a:solidFill>
-                  <a:srgbClr val="0B1B2D"/>
-                </a:solidFill>
-              </a:defRPr>
-            </a:pPr>
-            <a:r>
-              <a:t>• </a:t>
-            </a:r>
-          </a:p>
-          <a:p>
-            <a:pPr>
-              <a:spcAft>
-                <a:spcPts val="400"/>
-              </a:spcAft>
-              <a:defRPr sz="1200">
-                <a:solidFill>
-                  <a:srgbClr val="0B1B2D"/>
-                </a:solidFill>
-              </a:defRPr>
-            </a:pPr>
-            <a:r>
-              <a:t>• Test suite: parser_test.go (valid + superseded + supersedes + invalid cases)</a:t>
-            </a:r>
-          </a:p>
-          <a:p>
-            <a:pPr>
-              <a:spcAft>
-                <a:spcPts val="400"/>
-              </a:spcAft>
-              <a:defRPr sz="1200">
-                <a:solidFill>
-                  <a:srgbClr val="0B1B2D"/>
-                </a:solidFill>
-              </a:defRPr>
-            </a:pPr>
-            <a:r>
-              <a:t>• Test suite: linter_test.go (valid sequence + 7 broken reference scenarios + concurrency)</a:t>
+              <a:t>• ADR 0003: Event Sourcing | Rejected (alasan biaya operasional)</a:t>
             </a:r>
           </a:p>
         </p:txBody>
@@ -16867,7 +15876,7 @@
               </a:defRPr>
             </a:pPr>
             <a:r>
-              <a:t>Eksperimen lab ini memodelkan tiga skenario ADR yang merepresentasikan evolusi arsitektur nyata. ADR 1 merekam keputusan awal menggunakan Modular Monolith. ADR 2 menggantikan ADR 1 setelah tim tumbuh melebihi 20 engineer dan membutuhkan scaling independen untuk notification service. ADR 3 menolak usulan Event Sourcing karena kebutuhan audit trail masih terpenuhi oleh relational log table standar. Ketiganya divalidasi bersama melalui linter untuk memastikan konsistensi lineagenya.</a:t>
+              <a:t>Eksperimen memvalidasi tiga ADR nyata: monolit awal, pemisahan service pengganti, dan usulan ditolak agar argumen penolakan tidak didebatkan ulang.</a:t>
             </a:r>
           </a:p>
         </p:txBody>
@@ -16919,7 +15928,7 @@
               </a:defRPr>
             </a:pPr>
             <a:r>
-              <a:t>Three ADRs capture one realistic architectural evolution path with valid lineage.</a:t>
+              <a:t>Three records demonstrate full lifecycle: active, superseded, and rejected.</a:t>
             </a:r>
           </a:p>
         </p:txBody>
@@ -16954,7 +15963,7 @@
               </a:defRPr>
             </a:pPr>
             <a:r>
-              <a:t>cmd/demo/main.go • tests/linter_test.go</a:t>
+              <a:t>cmd/demo/main.go</a:t>
             </a:r>
           </a:p>
         </p:txBody>

</xml_diff>

<commit_message>
style(17-architecture-decision-record): apply professional carousel layout and editorial polish
- Refactor slide 5 into 4-stage visual flow layout (Markdown -> Parser -> Linter -> Errors)
- Convert slide 9 ADR sequence into 3 focused decision cards
- Format slide 14 into before-vs-after comparison cards and slide 20 into checklist layout
- Remove long competing paragraphs and eliminate unnatural tokens (mengklaim, broken_references)
- Rebuild LinkedIn PDF/PPTX carousel, Dev.to markdown, and Medium HTML deliverables
</commit_message>
<xml_diff>
--- a/labs/17-architecture-decision-record/result/linkedin/lab-17-architecture-decision-record-carousel.pptx
+++ b/labs/17-architecture-decision-record/result/linkedin/lab-17-architecture-decision-record-carousel.pptx
@@ -772,7 +772,12 @@
           </a:p>
           <a:p>
             <a:r>
-              <a:t>- Apakah microservice memang solusi tepat bagi tim.</a:t>
+              <a:t>- Apakah rancangan arsitektur tepat untuk kapasitas tim.</a:t>
+            </a:r>
+          </a:p>
+          <a:p>
+            <a:r>
+              <a:t>- Evaluasi dampak performa dan biaya operasional sistem.</a:t>
             </a:r>
           </a:p>
           <a:p/>
@@ -843,7 +848,7 @@
           <a:lstStyle/>
           <a:p>
             <a:r>
-              <a:t>SLIDE 12: Trade-off: Struktur Kaku vs Fleksibilitas</a:t>
+              <a:t>SLIDE 12: Trade-off: Struktur Baku vs Fleksibilitas</a:t>
             </a:r>
           </a:p>
           <a:p/>
@@ -860,7 +865,7 @@
           </a:p>
           <a:p>
             <a:r>
-              <a:t>- Wajib tiga section: Context, Decision, Consequences.</a:t>
+              <a:t>- Wajib tiga bagian: Context, Decision, Consequences.</a:t>
             </a:r>
           </a:p>
           <a:p>
@@ -880,12 +885,17 @@
           </a:p>
           <a:p>
             <a:r>
-              <a:t>- Tidak mendukung format paragraf naratif bebas.</a:t>
+              <a:t>- Tidak mendukung format narasi paragraf bebas.</a:t>
             </a:r>
           </a:p>
           <a:p>
             <a:r>
               <a:t>- Memerlukan disiplin tim mengisi field relasi.</a:t>
+            </a:r>
+          </a:p>
+          <a:p>
+            <a:r>
+              <a:t>- Perubahan format membutuhkan penyesuaian parser.</a:t>
             </a:r>
           </a:p>
           <a:p/>
@@ -1131,7 +1141,7 @@
           </a:p>
           <a:p>
             <a:r>
-              <a:t>- Nomor ID wajib monotonik dan unik.</a:t>
+              <a:t>- Nomor ID wajib monotonik dan teratur.</a:t>
             </a:r>
           </a:p>
           <a:p>
@@ -1249,7 +1259,7 @@
           </a:p>
           <a:p>
             <a:r>
-              <a:t>- Simulasi in-memory, bukan pembacaan ribuan file disk.</a:t>
+              <a:t>- Simulasi in-memory, bukan pembacaan ribuan berkas disk.</a:t>
             </a:r>
           </a:p>
           <a:p/>
@@ -1347,7 +1357,7 @@
           </a:p>
           <a:p>
             <a:r>
-              <a:t>- Menghapus file justru menghilangkan konteks historis.</a:t>
+              <a:t>- Menghapus berkas justru menghilangkan riwayat konteks.</a:t>
             </a:r>
           </a:p>
           <a:p>
@@ -1538,7 +1548,7 @@
           </a:p>
           <a:p>
             <a:r>
-              <a:t>- Kebenaran konten teknis di dalam section Decision.</a:t>
+              <a:t>- Kebenaran konten teknis di dalam bagian Decision.</a:t>
             </a:r>
           </a:p>
           <a:p>
@@ -1641,7 +1651,7 @@
           </a:p>
           <a:p>
             <a:r>
-              <a:t>- Dokumen lolos linter meski bagian Decision hanya berisi teks formalitas.</a:t>
+              <a:t>- Dokumen lolos linter meski bagian Decision hanya teks formalitas.</a:t>
             </a:r>
           </a:p>
           <a:p>
@@ -1651,7 +1661,7 @@
           </a:p>
           <a:p>
             <a:r>
-              <a:t>- Mitigasi: pertahankan review arsitek untuk menilai isi substansi.</a:t>
+              <a:t>- Mitigasi: pertahankan review arsitek untuk menilai substansi.</a:t>
             </a:r>
           </a:p>
           <a:p/>
@@ -1837,22 +1847,22 @@
           </a:p>
           <a:p>
             <a:r>
-              <a:t>- [ ] Tetapkan template Markdown dengan Context, Decision, Consequences.</a:t>
-            </a:r>
-          </a:p>
-          <a:p>
-            <a:r>
-              <a:t>- [ ] Gunakan enum status resmi (Accepted, Superseded, Rejected, dll.).</a:t>
-            </a:r>
-          </a:p>
-          <a:p>
-            <a:r>
-              <a:t>- [ ] Pasang parser dan linter pada pull request CI gate.</a:t>
-            </a:r>
-          </a:p>
-          <a:p>
-            <a:r>
-              <a:t>- [ ] Larang edit retroaktif: keputusan baru wajib nomor ADR baru.</a:t>
+              <a:t>- Tetapkan template berkas: Context, Decision, Consequences.</a:t>
+            </a:r>
+          </a:p>
+          <a:p>
+            <a:r>
+              <a:t>- Gunakan enum status resmi (Accepted, Superseded, Rejected).</a:t>
+            </a:r>
+          </a:p>
+          <a:p>
+            <a:r>
+              <a:t>- Pasang parser dan linter pada CI gate pull request.</a:t>
+            </a:r>
+          </a:p>
+          <a:p>
+            <a:r>
+              <a:t>- Larang edit retroaktif: keputusan baru wajib nomor baru.</a:t>
             </a:r>
           </a:p>
           <a:p/>
@@ -2053,7 +2063,7 @@
           </a:p>
           <a:p>
             <a:r>
-              <a:t>- go test -race ./... # cek race condition</a:t>
+              <a:t>- go test -race ./... # verifikasi race-free</a:t>
             </a:r>
           </a:p>
           <a:p>
@@ -2558,27 +2568,27 @@
           <a:p/>
           <a:p>
             <a:r>
-              <a:t>[VALIDATION PIPELINE]</a:t>
-            </a:r>
-          </a:p>
-          <a:p>
-            <a:r>
-              <a:t>- Markdown Files → adr.Parser (ekstraksi field &amp; status)</a:t>
-            </a:r>
-          </a:p>
-          <a:p>
-            <a:r>
-              <a:t>- → []*adr.Record (in-memory struct)</a:t>
-            </a:r>
-          </a:p>
-          <a:p>
-            <a:r>
-              <a:t>- → adr.Linter (cek urutan ID, siklus, &amp; relasi timbal-balik)</a:t>
-            </a:r>
-          </a:p>
-          <a:p>
-            <a:r>
-              <a:t>- → []error (laporan pelanggaran integritas)</a:t>
+              <a:t>[]</a:t>
+            </a:r>
+          </a:p>
+          <a:p>
+            <a:r>
+              <a:t>- Markdown Files | Format teks mentah</a:t>
+            </a:r>
+          </a:p>
+          <a:p>
+            <a:r>
+              <a:t>- adr.Parser | Ekstraksi struct Record</a:t>
+            </a:r>
+          </a:p>
+          <a:p>
+            <a:r>
+              <a:t>- adr.Linter | Aturan &amp; integritas graf</a:t>
+            </a:r>
+          </a:p>
+          <a:p>
+            <a:r>
+              <a:t>- Laporan Error | Deteksi inkonsistensi</a:t>
             </a:r>
           </a:p>
           <a:p/>
@@ -2784,7 +2794,7 @@
           <a:p/>
           <a:p>
             <a:r>
-              <a:t>[TEST CASE: broken_references]</a:t>
+              <a:t>[KASUS UJI: REFERENSI PATAH]</a:t>
             </a:r>
           </a:p>
           <a:p>
@@ -2995,22 +3005,22 @@
           <a:p/>
           <a:p>
             <a:r>
-              <a:t>[URUTAN KEPUTUSAN]</a:t>
-            </a:r>
-          </a:p>
-          <a:p>
-            <a:r>
-              <a:t>- ADR 0001: Modular Monolith | Superseded by ADR 2</a:t>
-            </a:r>
-          </a:p>
-          <a:p>
-            <a:r>
-              <a:t>- ADR 0002: Notification Microservice | Accepted, Supersedes ADR 1</a:t>
-            </a:r>
-          </a:p>
-          <a:p>
-            <a:r>
-              <a:t>- ADR 0003: Event Sourcing | Rejected (alasan biaya operasional)</a:t>
+              <a:t>[]</a:t>
+            </a:r>
+          </a:p>
+          <a:p>
+            <a:r>
+              <a:t>- ADR 0001: Modular Monolith</a:t>
+            </a:r>
+          </a:p>
+          <a:p>
+            <a:r>
+              <a:t>- ADR 0002: Notification Microservice</a:t>
+            </a:r>
+          </a:p>
+          <a:p>
+            <a:r>
+              <a:t>- ADR 0003: Event Sourcing</a:t>
             </a:r>
           </a:p>
           <a:p/>
@@ -6500,7 +6510,7 @@
               </a:defRPr>
             </a:pPr>
             <a:r>
-              <a:t>CLI memverifikasi rantai lineage: ADR 1 dan ADR 2 saling terhubung konsisten, nomor urut rapi, dan tidak ada siklus.</a:t>
+              <a:t>CLI memverifikasi rantai silsilah: ADR 1 dan ADR 2 terhubung konsisten, nomor urut rapi, dan tidak ada siklus.</a:t>
             </a:r>
           </a:p>
         </p:txBody>
@@ -6910,7 +6920,22 @@
               </a:defRPr>
             </a:pPr>
             <a:r>
-              <a:t>• Apakah microservice memang solusi tepat bagi tim.</a:t>
+              <a:t>• Apakah rancangan arsitektur tepat untuk kapasitas tim.</a:t>
+            </a:r>
+          </a:p>
+          <a:p>
+            <a:pPr>
+              <a:spcAft>
+                <a:spcPts val="400"/>
+              </a:spcAft>
+              <a:defRPr sz="1200">
+                <a:solidFill>
+                  <a:srgbClr val="0B1B2D"/>
+                </a:solidFill>
+              </a:defRPr>
+            </a:pPr>
+            <a:r>
+              <a:t>• Evaluasi dampak performa dan biaya operasional sistem.</a:t>
             </a:r>
           </a:p>
         </p:txBody>
@@ -6948,7 +6973,12 @@
               </a:defRPr>
             </a:pPr>
             <a:r>
-              <a:t>Linter hanya memastikan dokumen rapi dan tautannya konsisten. Ia tidak bisa menilai apakah keputusan microservice benar secara arsitektur. Kualitas keputusan tetap tanggung jawab tim.</a:t>
+              <a:t>Nomor ID berurutan tanpa celah. Relasi timbal-balik utuh tanpa tautan gantung. Tidak ada siklus ketergantungan antar-dokumen.</a:t>
+            </a:r>
+            <a:br/>
+            <a:br/>
+            <a:r>
+              <a:t>Kebenaran argumen teknis di bagian Decision. Apakah rancangan arsitektur tepat untuk kapasitas tim. Evaluasi dampak performa dan biaya operasional sistem.</a:t>
             </a:r>
           </a:p>
         </p:txBody>
@@ -7201,7 +7231,7 @@
               </a:defRPr>
             </a:pPr>
             <a:r>
-              <a:t>Trade-off: Struktur Kaku vs Fleksibilitas</a:t>
+              <a:t>Trade-off: Struktur Baku vs Fleksibilitas</a:t>
             </a:r>
           </a:p>
         </p:txBody>
@@ -7286,7 +7316,7 @@
               </a:defRPr>
             </a:pPr>
             <a:r>
-              <a:t>• Wajib tiga section: Context, Decision, Consequences.</a:t>
+              <a:t>• Wajib tiga bagian: Context, Decision, Consequences.</a:t>
             </a:r>
           </a:p>
           <a:p>
@@ -7343,7 +7373,7 @@
               </a:defRPr>
             </a:pPr>
             <a:r>
-              <a:t>• Tidak mendukung format paragraf naratif bebas.</a:t>
+              <a:t>• Tidak mendukung format narasi paragraf bebas.</a:t>
             </a:r>
           </a:p>
           <a:p>
@@ -7361,6 +7391,21 @@
               <a:t>• Memerlukan disiplin tim mengisi field relasi.</a:t>
             </a:r>
           </a:p>
+          <a:p>
+            <a:pPr>
+              <a:spcAft>
+                <a:spcPts val="400"/>
+              </a:spcAft>
+              <a:defRPr sz="1200">
+                <a:solidFill>
+                  <a:srgbClr val="0B1B2D"/>
+                </a:solidFill>
+              </a:defRPr>
+            </a:pPr>
+            <a:r>
+              <a:t>• Perubahan format membutuhkan penyesuaian parser.</a:t>
+            </a:r>
+          </a:p>
         </p:txBody>
       </p:sp>
       <p:sp>
@@ -7396,7 +7441,12 @@
               </a:defRPr>
             </a:pPr>
             <a:r>
-              <a:t>Format baku membuat dokumen bisa divalidasi mesin di CI. Biayanya: engineer tidak bisa lagi menulis catatan bebas tanpa mengikuti struktur.</a:t>
+              <a:t>Wajib tiga bagian: Context, Decision, Consequences. Status dibatasi lima enum resmi. Memungkinkan CI gate otomatis dan deterministik.</a:t>
+            </a:r>
+            <a:br/>
+            <a:br/>
+            <a:r>
+              <a:t>Tidak mendukung format narasi paragraf bebas. Memerlukan disiplin tim mengisi field relasi. Perubahan format membutuhkan penyesuaian parser.</a:t>
             </a:r>
           </a:p>
         </p:txBody>
@@ -7811,7 +7861,7 @@
               </a:defRPr>
             </a:pPr>
             <a:r>
-              <a:t>Validasi konkuren mengumpulkan error memakai mutex. Pola ini race-safe pada test, tetapi nilai utamanya ada pada kejelasan aturan, bukan kecepatan komputasi.</a:t>
+              <a:t>Validasi paralel mengumpulkan error secara race-safe memakai mutex. Pola ini terbukti aman pada pengujian konkurensi Go.</a:t>
             </a:r>
           </a:p>
         </p:txBody>
@@ -8221,7 +8271,7 @@
               </a:defRPr>
             </a:pPr>
             <a:r>
-              <a:t>• Nomor ID wajib monotonik dan unik.</a:t>
+              <a:t>• Nomor ID wajib monotonik dan teratur.</a:t>
             </a:r>
           </a:p>
           <a:p>
@@ -8274,7 +8324,12 @@
               </a:defRPr>
             </a:pPr>
             <a:r>
-              <a:t>Linter menutup human error pada aspek mekanis: tautan sepihak, nomor loncat, dan status informal. Arsitek bisa fokus meninjau substansi keputusan.</a:t>
+              <a:t>Tautan supersesi sepihak sering terlewat. Nomor meloncat sulit disadari saat banyak file. Status non-standar masuk tanpa sengaja.</a:t>
+            </a:r>
+            <a:br/>
+            <a:br/>
+            <a:r>
+              <a:t>Semua inkonsistensi ditolak otomatis di CI. Nomor ID wajib monotonik dan teratur. Relasi timbal-balik divalidasi deterministik.</a:t>
             </a:r>
           </a:p>
         </p:txBody>
@@ -8684,7 +8739,7 @@
               </a:defRPr>
             </a:pPr>
             <a:r>
-              <a:t>• Simulasi in-memory, bukan pembacaan ribuan file disk.</a:t>
+              <a:t>• Simulasi in-memory, bukan pembacaan ribuan berkas disk.</a:t>
             </a:r>
           </a:p>
         </p:txBody>
@@ -8722,7 +8777,12 @@
               </a:defRPr>
             </a:pPr>
             <a:r>
-              <a:t>Lab ini memvalidasi aturan dokumen, bukan kebenaran arsitektur. Parsing regex bekerja pada memori; pengujian tidak membuktikan seluruh perilaku repositori skala raksasa.</a:t>
+              <a:t>Ekstraksi regex dari string Markdown. Pemeriksaan nomor urut dan relasi timbal-balik. Deteksi siklus pada graf supersesi.</a:t>
+            </a:r>
+            <a:br/>
+            <a:br/>
+            <a:r>
+              <a:t>Tidak menilai kebenaran argumen keputusan. Simulasi in-memory, bukan pembacaan ribuan berkas disk.</a:t>
             </a:r>
           </a:p>
         </p:txBody>
@@ -9090,7 +9150,7 @@
               </a:defRPr>
             </a:pPr>
             <a:r>
-              <a:t>• Menghapus file justru menghilangkan konteks historis.</a:t>
+              <a:t>• Menghapus berkas justru menghilangkan riwayat konteks.</a:t>
             </a:r>
           </a:p>
           <a:p>
@@ -9887,7 +9947,7 @@
               </a:defRPr>
             </a:pPr>
             <a:r>
-              <a:t>• Kebenaran konten teknis di dalam section Decision.</a:t>
+              <a:t>• Kebenaran konten teknis di dalam bagian Decision.</a:t>
             </a:r>
           </a:p>
           <a:p>
@@ -10308,7 +10368,7 @@
               </a:defRPr>
             </a:pPr>
             <a:r>
-              <a:t>• Dokumen lolos linter meski bagian Decision hanya berisi teks formalitas.</a:t>
+              <a:t>• Dokumen lolos linter meski bagian Decision hanya teks formalitas.</a:t>
             </a:r>
           </a:p>
           <a:p>
@@ -10338,7 +10398,7 @@
               </a:defRPr>
             </a:pPr>
             <a:r>
-              <a:t>• Mitigasi: pertahankan review arsitek untuk menilai isi substansi.</a:t>
+              <a:t>• Mitigasi: pertahankan review arsitek untuk menilai substansi.</a:t>
             </a:r>
           </a:p>
         </p:txBody>
@@ -11120,7 +11180,7 @@
               </a:defRPr>
             </a:pPr>
             <a:r>
-              <a:t>• [ ] Tetapkan template Markdown dengan Context, Decision, Consequences.</a:t>
+              <a:t>• Tetapkan template berkas: Context, Decision, Consequences.</a:t>
             </a:r>
           </a:p>
           <a:p>
@@ -11135,7 +11195,7 @@
               </a:defRPr>
             </a:pPr>
             <a:r>
-              <a:t>• [ ] Gunakan enum status resmi (Accepted, Superseded, Rejected, dll.).</a:t>
+              <a:t>• Gunakan enum status resmi (Accepted, Superseded, Rejected).</a:t>
             </a:r>
           </a:p>
           <a:p>
@@ -11150,7 +11210,7 @@
               </a:defRPr>
             </a:pPr>
             <a:r>
-              <a:t>• [ ] Pasang parser dan linter pada pull request CI gate.</a:t>
+              <a:t>• Pasang parser dan linter pada CI gate pull request.</a:t>
             </a:r>
           </a:p>
           <a:p>
@@ -11165,7 +11225,7 @@
               </a:defRPr>
             </a:pPr>
             <a:r>
-              <a:t>• [ ] Larang edit retroaktif: keputusan baru wajib nomor ADR baru.</a:t>
+              <a:t>• Larang edit retroaktif: keputusan baru wajib nomor baru.</a:t>
             </a:r>
           </a:p>
         </p:txBody>
@@ -11203,7 +11263,7 @@
               </a:defRPr>
             </a:pPr>
             <a:r>
-              <a:t>Implementasi sukses menggabungkan template terstandar dan CI gate otomatis. Aturan terpenting: jangan ubah ADR lama secara retroaktif; buat catatan baru jika arah berubah.</a:t>
+              <a:t>Tetapkan template berkas: Context, Decision, Consequences. Gunakan enum status resmi (Accepted, Superseded, Rejected). Pasang parser dan linter pada CI gate pull request. Larang edit retroaktif: keputusan baru wajib nomor baru.</a:t>
             </a:r>
           </a:p>
         </p:txBody>
@@ -11624,7 +11684,7 @@
               </a:defRPr>
             </a:pPr>
             <a:r>
-              <a:t>Anti-pattern paling berbahaya adalah suntingan diam-diam pada keputusan lama. Hal ini menghapus riwayat pembelajaran tim dan memicu asumsi keliru bagi engineer baru.</a:t>
+              <a:t>Anti-pattern paling berbahaya adalah suntingan diam-diam pada keputusan lama. Hal ini menghapus riwayat pembelajaran tim dan memicu kebingungan bagi engineer baru.</a:t>
             </a:r>
           </a:p>
         </p:txBody>
@@ -11912,7 +11972,7 @@
               </a:defRPr>
             </a:pPr>
             <a:r>
-              <a:t>Eksperimen dijalankan dengan Go standard library tanpa dependency luar.</a:t>
+              <a:t>Eksperimen dijalankan dengan Go standard library tanpa dependency eksternal.</a:t>
             </a:r>
           </a:p>
         </p:txBody>
@@ -11973,7 +12033,7 @@
             </a:r>
             <a:br/>
             <a:r>
-              <a:t>go test -race ./... # cek race condition</a:t>
+              <a:t>go test -race ./... # verifikasi race-free</a:t>
             </a:r>
             <a:br/>
             <a:r>
@@ -12015,7 +12075,7 @@
               </a:defRPr>
             </a:pPr>
             <a:r>
-              <a:t>Lab ini zero-dependency dan dapat direproduksi langsung. Menjalankan demo dan test membuktikan parser dan linter bekerja secara mandiri di lokal.</a:t>
+              <a:t>Lab ini zero-dependency dan dapat direproduksi langsung. Menjalankan demo dan test membuktikan parser dan linter bekerja secara mandiri di mesin lokal.</a:t>
             </a:r>
           </a:p>
         </p:txBody>
@@ -13207,7 +13267,7 @@
               </a:defRPr>
             </a:pPr>
             <a:r>
-              <a:t>Masalah terbesar review manual adalah supersesi yang tidak sinkron. ADR baru mengklaim menggantikan, tetapi ADR lama tetap bertanda aktif karena lupa diperbarui.</a:t>
+              <a:t>Masalah terbesar review manual adalah supersesi yang tidak sinkron. ADR baru menyatakan menggantikan, tetapi ADR lama tetap bertanda aktif karena lupa diperbarui.</a:t>
             </a:r>
           </a:p>
         </p:txBody>
@@ -13613,7 +13673,7 @@
               </a:defRPr>
             </a:pPr>
             <a:r>
-              <a:t>ADR bukan sekadar dokumen naratif. Saat diubah menjadi struct Record, mesin bisa mengekstrak field kunci dan memeriksa konsistensi yang sering terlewat oleh manusia.</a:t>
+              <a:t>ADR bukan sekadar dokumen naratif. Saat diubah menjadi struct Record, mesin bisa mengekstrak field kunci dan memeriksa konsistensi secara otomatis.</a:t>
             </a:r>
           </a:p>
         </p:txBody>
@@ -13935,9 +13995,6 @@
                 </a:solidFill>
               </a:defRPr>
             </a:pPr>
-            <a:r>
-              <a:t>VALIDATION PIPELINE</a:t>
-            </a:r>
           </a:p>
           <a:p>
             <a:pPr>
@@ -13951,7 +14008,7 @@
               </a:defRPr>
             </a:pPr>
             <a:r>
-              <a:t>Markdown Files → adr.Parser (ekstraksi field &amp; status)</a:t>
+              <a:t>• Markdown Files | Format teks mentah</a:t>
             </a:r>
           </a:p>
           <a:p>
@@ -13966,7 +14023,7 @@
               </a:defRPr>
             </a:pPr>
             <a:r>
-              <a:t>→ []*adr.Record (in-memory struct)</a:t>
+              <a:t>• adr.Parser | Ekstraksi struct Record</a:t>
             </a:r>
           </a:p>
           <a:p>
@@ -13981,7 +14038,7 @@
               </a:defRPr>
             </a:pPr>
             <a:r>
-              <a:t>→ adr.Linter (cek urutan ID, siklus, &amp; relasi timbal-balik)</a:t>
+              <a:t>• adr.Linter | Aturan &amp; integritas graf</a:t>
             </a:r>
           </a:p>
           <a:p>
@@ -13996,7 +14053,7 @@
               </a:defRPr>
             </a:pPr>
             <a:r>
-              <a:t>→ []error (laporan pelanggaran integritas)</a:t>
+              <a:t>• Laporan Error | Deteksi inkonsistensi</a:t>
             </a:r>
           </a:p>
         </p:txBody>
@@ -14441,7 +14498,7 @@
               </a:defRPr>
             </a:pPr>
             <a:r>
-              <a:t>Struct Record mendefinisikan field wajib secara eksplisit. Dengan representasi integer dan enum, linter memeriksa aturan tanpa perlu menebak teks bebas.</a:t>
+              <a:t>Struct Record mendefinisikan field wajib secara eksplisit. Dengan integer dan enum, linter memeriksa aturan tanpa perlu menebak teks bebas.</a:t>
             </a:r>
           </a:p>
         </p:txBody>
@@ -15792,9 +15849,6 @@
                 </a:solidFill>
               </a:defRPr>
             </a:pPr>
-            <a:r>
-              <a:t>URUTAN KEPUTUSAN</a:t>
-            </a:r>
           </a:p>
           <a:p>
             <a:pPr>
@@ -15808,7 +15862,7 @@
               </a:defRPr>
             </a:pPr>
             <a:r>
-              <a:t>• ADR 0001: Modular Monolith | Superseded by ADR 2</a:t>
+              <a:t>• ADR 0001: Modular Monolith (Superseded by ADR 2)</a:t>
             </a:r>
           </a:p>
           <a:p>
@@ -15823,7 +15877,7 @@
               </a:defRPr>
             </a:pPr>
             <a:r>
-              <a:t>• ADR 0002: Notification Microservice | Accepted, Supersedes ADR 1</a:t>
+              <a:t>• ADR 0002: Notification Microservice (Accepted • Supersedes ADR 1)</a:t>
             </a:r>
           </a:p>
           <a:p>
@@ -15838,7 +15892,7 @@
               </a:defRPr>
             </a:pPr>
             <a:r>
-              <a:t>• ADR 0003: Event Sourcing | Rejected (alasan biaya operasional)</a:t>
+              <a:t>• ADR 0003: Event Sourcing (Rejected • Biaya operasional tinggi)</a:t>
             </a:r>
           </a:p>
         </p:txBody>
@@ -15876,7 +15930,7 @@
               </a:defRPr>
             </a:pPr>
             <a:r>
-              <a:t>Eksperimen memvalidasi tiga ADR nyata: monolit awal, pemisahan service pengganti, dan usulan ditolak agar argumen penolakan tidak didebatkan ulang.</a:t>
+              <a:t>Eksperimen memvalidasi tiga ADR nyata: monolit awal, service pengganti, dan usulan ditolak agar argumen penolakan tidak diperdebatkan ulang.</a:t>
             </a:r>
           </a:p>
         </p:txBody>

</xml_diff>

<commit_message>
style(cover): apply poster-grade hero visual and fix thumbnail regression
</commit_message>
<xml_diff>
--- a/labs/17-architecture-decision-record/result/linkedin/lab-17-architecture-decision-record-carousel.pptx
+++ b/labs/17-architecture-decision-record/result/linkedin/lab-17-architecture-decision-record-carousel.pptx
@@ -6177,63 +6177,35 @@
       </p:sp>
       <p:sp>
         <p:nvSpPr>
-          <p:cNvPr id="6" name="Rounded Rectangle 5"/>
-          <p:cNvSpPr/>
-          <p:nvPr/>
-        </p:nvSpPr>
-        <p:spPr>
-          <a:xfrm>
-            <a:off x="914400" y="4389120"/>
-            <a:ext cx="10362895" cy="1645920"/>
-          </a:xfrm>
-          <a:prstGeom prst="roundRect">
-            <a:avLst/>
-          </a:prstGeom>
-          <a:solidFill>
-            <a:srgbClr val="1E293B"/>
-          </a:solidFill>
-          <a:ln>
-            <a:solidFill>
-              <a:srgbClr val="087F76"/>
-            </a:solidFill>
-          </a:ln>
-        </p:spPr>
-        <p:style>
-          <a:lnRef idx="1">
-            <a:schemeClr val="accent1"/>
-          </a:lnRef>
-          <a:fillRef idx="3">
-            <a:schemeClr val="accent1"/>
-          </a:fillRef>
-          <a:effectRef idx="2">
-            <a:schemeClr val="accent1"/>
-          </a:effectRef>
-          <a:fontRef idx="minor">
-            <a:schemeClr val="lt1"/>
-          </a:fontRef>
-        </p:style>
-        <p:txBody>
-          <a:bodyPr rtlCol="0" anchor="ctr" wrap="square"/>
-          <a:lstStyle/>
-          <a:p>
-            <a:pPr algn="ctr">
-              <a:defRPr sz="1500">
-                <a:solidFill>
-                  <a:srgbClr val="087F76"/>
-                </a:solidFill>
-                <a:latin typeface="Courier New"/>
-              </a:defRPr>
-            </a:pPr>
-            <a:r>
-              <a:t>&gt; system_check --lab 17 --topic 'architecture-decision-record'</a:t>
-            </a:r>
-            <a:br/>
-            <a:r>
-              <a:t>&gt; author: Lukman / lukman-ss | status: PRODUCTION VERIFIED</a:t>
-            </a:r>
-            <a:br/>
-            <a:r>
-              <a:t>&gt; commit: def0f5a | tests: PASS</a:t>
+          <p:cNvPr id="6" name="TextBox 5"/>
+          <p:cNvSpPr txBox="1"/>
+          <p:nvPr/>
+        </p:nvSpPr>
+        <p:spPr>
+          <a:xfrm>
+            <a:off x="914400" y="5303520"/>
+            <a:ext cx="5486400" cy="548640"/>
+          </a:xfrm>
+          <a:prstGeom prst="rect">
+            <a:avLst/>
+          </a:prstGeom>
+          <a:noFill/>
+        </p:spPr>
+        <p:txBody>
+          <a:bodyPr wrap="none">
+            <a:spAutoFit/>
+          </a:bodyPr>
+          <a:lstStyle/>
+          <a:p>
+            <a:pPr>
+              <a:defRPr sz="1800" b="1">
+                <a:solidFill>
+                  <a:srgbClr val="D97706"/>
+                </a:solidFill>
+              </a:defRPr>
+            </a:pPr>
+            <a:r>
+              <a:t>Lukman / lukman-ss</a:t>
             </a:r>
           </a:p>
         </p:txBody>

</xml_diff>